<commit_message>
Add LinkedIn QR to the find-me slide
Co-Authored-By: Claude Opus 4.8 <noreply@anthropic.com>
</commit_message>
<xml_diff>
--- a/presentation/founsi-context-engineering.pptx
+++ b/presentation/founsi-context-engineering.pptx
@@ -9182,8 +9182,8 @@
         </p:blipFill>
         <p:spPr>
           <a:xfrm>
-            <a:off x="1097280" y="2011680"/>
-            <a:ext cx="1371600" cy="1371600"/>
+            <a:off x="868680" y="2103120"/>
+            <a:ext cx="1143000" cy="1143000"/>
           </a:xfrm>
           <a:prstGeom prst="rect">
             <a:avLst/>
@@ -9198,8 +9198,8 @@
         </p:nvSpPr>
         <p:spPr>
           <a:xfrm>
-            <a:off x="822960" y="3429000"/>
-            <a:ext cx="1920240" cy="274320"/>
+            <a:off x="594360" y="3291840"/>
+            <a:ext cx="1691640" cy="274320"/>
           </a:xfrm>
           <a:prstGeom prst="rect">
             <a:avLst/>
@@ -9245,8 +9245,8 @@
         </p:blipFill>
         <p:spPr>
           <a:xfrm>
-            <a:off x="3886200" y="2011680"/>
-            <a:ext cx="1371600" cy="1371600"/>
+            <a:off x="2971800" y="2103120"/>
+            <a:ext cx="1143000" cy="1143000"/>
           </a:xfrm>
           <a:prstGeom prst="rect">
             <a:avLst/>
@@ -9261,8 +9261,8 @@
         </p:nvSpPr>
         <p:spPr>
           <a:xfrm>
-            <a:off x="3611880" y="3429000"/>
-            <a:ext cx="1920240" cy="274320"/>
+            <a:off x="2697480" y="3291840"/>
+            <a:ext cx="1691640" cy="274320"/>
           </a:xfrm>
           <a:prstGeom prst="rect">
             <a:avLst/>
@@ -9308,8 +9308,8 @@
         </p:blipFill>
         <p:spPr>
           <a:xfrm>
-            <a:off x="6675120" y="2011680"/>
-            <a:ext cx="1371600" cy="1371600"/>
+            <a:off x="5074920" y="2103120"/>
+            <a:ext cx="1143000" cy="1143000"/>
           </a:xfrm>
           <a:prstGeom prst="rect">
             <a:avLst/>
@@ -9324,8 +9324,8 @@
         </p:nvSpPr>
         <p:spPr>
           <a:xfrm>
-            <a:off x="6400800" y="3429000"/>
-            <a:ext cx="1920240" cy="274320"/>
+            <a:off x="4800600" y="3291840"/>
+            <a:ext cx="1691640" cy="274320"/>
           </a:xfrm>
           <a:prstGeom prst="rect">
             <a:avLst/>
@@ -9350,45 +9350,6 @@
                 <a:cs typeface="Manrope" pitchFamily="34" charset="-120"/>
               </a:rPr>
               <a:t>X · @above_almighty</a:t>
-            </a:r>
-            <a:endParaRPr lang="en-US" sz="1100" dirty="0"/>
-          </a:p>
-        </p:txBody>
-      </p:sp>
-      <p:sp>
-        <p:nvSpPr>
-          <p:cNvPr id="10" name="Text 5"/>
-          <p:cNvSpPr/>
-          <p:nvPr/>
-        </p:nvSpPr>
-        <p:spPr>
-          <a:xfrm>
-            <a:off x="548640" y="4160520"/>
-            <a:ext cx="8229600" cy="274320"/>
-          </a:xfrm>
-          <a:prstGeom prst="rect">
-            <a:avLst/>
-          </a:prstGeom>
-          <a:noFill/>
-          <a:ln/>
-        </p:spPr>
-        <p:txBody>
-          <a:bodyPr wrap="square" lIns="0" tIns="0" rIns="0" bIns="0" rtlCol="0" anchor="ctr"/>
-          <a:lstStyle/>
-          <a:p>
-            <a:pPr algn="ctr" indent="0" marL="0">
-              <a:buNone/>
-            </a:pPr>
-            <a:r>
-              <a:rPr lang="en-US" sz="1100" i="1" dirty="0">
-                <a:solidFill>
-                  <a:srgbClr val="7E7A8A"/>
-                </a:solidFill>
-                <a:latin typeface="Manrope" pitchFamily="34" charset="0"/>
-                <a:ea typeface="Manrope" pitchFamily="34" charset="-122"/>
-                <a:cs typeface="Manrope" pitchFamily="34" charset="-120"/>
-              </a:rPr>
-              <a:t>LinkedIn QR — add your URL (placeholder)</a:t>
             </a:r>
             <a:endParaRPr lang="en-US" sz="1100" dirty="0"/>
           </a:p>
@@ -9396,7 +9357,7 @@
       </p:sp>
       <p:pic>
         <p:nvPicPr>
-          <p:cNvPr id="11" name="Image 3" descr="preencoded.png">    </p:cNvPr>
+          <p:cNvPr id="10" name="Image 3" descr="/Users/kanishk/Desktop/agent-harness/.claude/worktrees/sleepy-sinoussi-00c73b/presentation/assets/qr/qr_linkedin.png">    </p:cNvPr>
           <p:cNvPicPr>
             <a:picLocks noChangeAspect="1"/>
           </p:cNvPicPr>
@@ -9410,6 +9371,69 @@
         </p:blipFill>
         <p:spPr>
           <a:xfrm>
+            <a:off x="7178040" y="2103120"/>
+            <a:ext cx="1143000" cy="1143000"/>
+          </a:xfrm>
+          <a:prstGeom prst="rect">
+            <a:avLst/>
+          </a:prstGeom>
+        </p:spPr>
+      </p:pic>
+      <p:sp>
+        <p:nvSpPr>
+          <p:cNvPr id="11" name="Text 5"/>
+          <p:cNvSpPr/>
+          <p:nvPr/>
+        </p:nvSpPr>
+        <p:spPr>
+          <a:xfrm>
+            <a:off x="6903720" y="3291840"/>
+            <a:ext cx="1691640" cy="274320"/>
+          </a:xfrm>
+          <a:prstGeom prst="rect">
+            <a:avLst/>
+          </a:prstGeom>
+          <a:noFill/>
+          <a:ln/>
+        </p:spPr>
+        <p:txBody>
+          <a:bodyPr wrap="square" lIns="0" tIns="0" rIns="0" bIns="0" rtlCol="0" anchor="ctr"/>
+          <a:lstStyle/>
+          <a:p>
+            <a:pPr algn="ctr" indent="0" marL="0">
+              <a:buNone/>
+            </a:pPr>
+            <a:r>
+              <a:rPr lang="en-US" sz="1100" b="1" dirty="0">
+                <a:solidFill>
+                  <a:srgbClr val="2E2C32"/>
+                </a:solidFill>
+                <a:latin typeface="Manrope" pitchFamily="34" charset="0"/>
+                <a:ea typeface="Manrope" pitchFamily="34" charset="-122"/>
+                <a:cs typeface="Manrope" pitchFamily="34" charset="-120"/>
+              </a:rPr>
+              <a:t>LinkedIn</a:t>
+            </a:r>
+            <a:endParaRPr lang="en-US" sz="1100" dirty="0"/>
+          </a:p>
+        </p:txBody>
+      </p:sp>
+      <p:pic>
+        <p:nvPicPr>
+          <p:cNvPr id="12" name="Image 4" descr="preencoded.png">    </p:cNvPr>
+          <p:cNvPicPr>
+            <a:picLocks noChangeAspect="1"/>
+          </p:cNvPicPr>
+          <p:nvPr/>
+        </p:nvPicPr>
+        <p:blipFill>
+          <a:blip r:embed="rId5"/>
+          <a:stretch>
+            <a:fillRect/>
+          </a:stretch>
+        </p:blipFill>
+        <p:spPr>
+          <a:xfrm>
             <a:off x="548640" y="4736592"/>
             <a:ext cx="219456" cy="165344"/>
           </a:xfrm>
@@ -9420,7 +9444,7 @@
       </p:pic>
       <p:sp>
         <p:nvSpPr>
-          <p:cNvPr id="12" name="Text 6"/>
+          <p:cNvPr id="13" name="Text 6"/>
           <p:cNvSpPr/>
           <p:nvPr/>
         </p:nvSpPr>
@@ -9473,7 +9497,7 @@
       </p:sp>
       <p:sp>
         <p:nvSpPr>
-          <p:cNvPr id="13" name="Text 7"/>
+          <p:cNvPr id="14" name="Text 7"/>
           <p:cNvSpPr/>
           <p:nvPr/>
         </p:nvSpPr>

</xml_diff>

<commit_message>
Parallel work: EXP-002 figure+slide, EXP-003b policy arms + judge, LoCoMo loader
While EXP-003a runs: (1) analyzed EXP-002 (length-degradation) — baseline recall
collapses 0.62->0.12 with length while summary compaction holds ~0.58; rendered the
recall-vs-length figure and updated deck slide 22 to the result. (2) Built the
remaining EXP-003b policy arms (importance, semantic, sub-agent isolation) and an
LLM judge, wired behind --judge, validated offline. (3) Added the LoCoMo loader +
a FRAMES pre-fetch utility for EXP-004. No API contention with the running 003a.

Co-Authored-By: Claude Opus 4.8 <noreply@anthropic.com>
</commit_message>
<xml_diff>
--- a/presentation/founsi-context-engineering.pptx
+++ b/presentation/founsi-context-engineering.pptx
@@ -8026,7 +8026,7 @@
                 <a:ea typeface="Syne" pitchFamily="34" charset="-122"/>
                 <a:cs typeface="Syne" pitchFamily="34" charset="-120"/>
               </a:rPr>
-              <a:t>EXP-002 · LENGTH-DEGRADATION (IN PROGRESS)</a:t>
+              <a:t>EXP-002 · LENGTH-DEGRADATION</a:t>
             </a:r>
             <a:endParaRPr lang="en-US" sz="1100" dirty="0"/>
           </a:p>
@@ -8057,7 +8057,7 @@
               <a:buNone/>
             </a:pPr>
             <a:r>
-              <a:rPr lang="en-US" sz="2400" b="1" dirty="0">
+              <a:rPr lang="en-US" sz="2500" b="1" dirty="0">
                 <a:solidFill>
                   <a:srgbClr val="2E2C32"/>
                 </a:solidFill>
@@ -8065,9 +8065,9 @@
                 <a:ea typeface="Syne" pitchFamily="34" charset="-122"/>
                 <a:cs typeface="Syne" pitchFamily="34" charset="-120"/>
               </a:rPr>
-              <a:t>Does compaction beat raw context?</a:t>
-            </a:r>
-            <a:endParaRPr lang="en-US" sz="2400" dirty="0"/>
+              <a:t>Does compaction beat raw context? Yes.</a:t>
+            </a:r>
+            <a:endParaRPr lang="en-US" sz="2500" dirty="0"/>
           </a:p>
         </p:txBody>
       </p:sp>
@@ -8187,94 +8187,40 @@
           </a:p>
         </p:txBody>
       </p:sp>
-      <p:sp>
-        <p:nvSpPr>
-          <p:cNvPr id="7" name="Text 4"/>
-          <p:cNvSpPr/>
-          <p:nvPr/>
-        </p:nvSpPr>
-        <p:spPr>
-          <a:xfrm>
-            <a:off x="548640" y="1371600"/>
-            <a:ext cx="8046720" cy="274320"/>
-          </a:xfrm>
-          <a:prstGeom prst="rect">
-            <a:avLst/>
-          </a:prstGeom>
-          <a:noFill/>
-          <a:ln/>
-        </p:spPr>
-        <p:txBody>
-          <a:bodyPr wrap="square" lIns="0" tIns="0" rIns="0" bIns="0" rtlCol="0" anchor="ctr"/>
-          <a:lstStyle/>
-          <a:p>
-            <a:pPr indent="0" marL="0">
-              <a:buNone/>
-            </a:pPr>
-            <a:r>
-              <a:rPr lang="en-US" sz="1300" b="1" dirty="0">
-                <a:solidFill>
-                  <a:srgbClr val="9378FF"/>
-                </a:solidFill>
-                <a:latin typeface="Manrope" pitchFamily="34" charset="0"/>
-                <a:ea typeface="Manrope" pitchFamily="34" charset="-122"/>
-                <a:cs typeface="Manrope" pitchFamily="34" charset="-120"/>
-              </a:rPr>
-              <a:t>Hypothesis</a:t>
-            </a:r>
-            <a:endParaRPr lang="en-US" sz="1300" dirty="0"/>
-          </a:p>
-        </p:txBody>
-      </p:sp>
-      <p:sp>
-        <p:nvSpPr>
-          <p:cNvPr id="8" name="Text 5"/>
-          <p:cNvSpPr/>
-          <p:nvPr/>
-        </p:nvSpPr>
-        <p:spPr>
-          <a:xfrm>
-            <a:off x="548640" y="1645920"/>
-            <a:ext cx="8046720" cy="685800"/>
-          </a:xfrm>
-          <a:prstGeom prst="rect">
-            <a:avLst/>
-          </a:prstGeom>
-          <a:noFill/>
-          <a:ln/>
-        </p:spPr>
-        <p:txBody>
-          <a:bodyPr wrap="square" lIns="0" tIns="0" rIns="0" bIns="0" rtlCol="0" anchor="ctr"/>
-          <a:lstStyle/>
-          <a:p>
-            <a:pPr indent="0" marL="0">
-              <a:buNone/>
-            </a:pPr>
-            <a:r>
-              <a:rPr lang="en-US" sz="1300" dirty="0">
-                <a:solidFill>
-                  <a:srgbClr val="2E2C32"/>
-                </a:solidFill>
-                <a:latin typeface="Manrope" pitchFamily="34" charset="0"/>
-                <a:ea typeface="Manrope" pitchFamily="34" charset="-122"/>
-                <a:cs typeface="Manrope" pitchFamily="34" charset="-120"/>
-              </a:rPr>
-              <a:t>As raw context grows, the no-compaction baseline's recall degrades (lost-in-the-middle); fixed-budget compaction holds recall higher at long lengths — the crossover is where compaction becomes net-positive.</a:t>
-            </a:r>
-            <a:endParaRPr lang="en-US" sz="1300" dirty="0"/>
-          </a:p>
-        </p:txBody>
-      </p:sp>
-      <p:sp>
-        <p:nvSpPr>
-          <p:cNvPr id="9" name="Text 6"/>
-          <p:cNvSpPr/>
-          <p:nvPr/>
-        </p:nvSpPr>
-        <p:spPr>
-          <a:xfrm>
-            <a:off x="548640" y="2468880"/>
-            <a:ext cx="8046720" cy="2834640"/>
+      <p:pic>
+        <p:nvPicPr>
+          <p:cNvPr id="7" name="Image 1" descr="/Users/kanishk/Desktop/agent-harness/.claude/worktrees/sleepy-sinoussi-00c73b/presentation/figures/EXP-002_recall_vs_length_v1.png">    </p:cNvPr>
+          <p:cNvPicPr>
+            <a:picLocks noChangeAspect="1"/>
+          </p:cNvPicPr>
+          <p:nvPr/>
+        </p:nvPicPr>
+        <p:blipFill>
+          <a:blip r:embed="rId2"/>
+          <a:stretch>
+            <a:fillRect/>
+          </a:stretch>
+        </p:blipFill>
+        <p:spPr>
+          <a:xfrm>
+            <a:off x="640080" y="1371600"/>
+            <a:ext cx="4846320" cy="3328416"/>
+          </a:xfrm>
+          <a:prstGeom prst="rect">
+            <a:avLst/>
+          </a:prstGeom>
+        </p:spPr>
+      </p:pic>
+      <p:sp>
+        <p:nvSpPr>
+          <p:cNvPr id="8" name="Text 4"/>
+          <p:cNvSpPr/>
+          <p:nvPr/>
+        </p:nvSpPr>
+        <p:spPr>
+          <a:xfrm>
+            <a:off x="5669280" y="1554480"/>
+            <a:ext cx="3017520" cy="2834640"/>
           </a:xfrm>
           <a:prstGeom prst="rect">
             <a:avLst/>
@@ -8294,7 +8240,7 @@
               <a:buChar char="•"/>
             </a:pPr>
             <a:r>
-              <a:rPr lang="en-US" sz="1300" dirty="0">
+              <a:rPr lang="en-US" sz="1250" dirty="0">
                 <a:solidFill>
                   <a:srgbClr val="2E2C32"/>
                 </a:solidFill>
@@ -8302,9 +8248,9 @@
                 <a:ea typeface="Manrope" pitchFamily="34" charset="-122"/>
                 <a:cs typeface="Manrope" pitchFamily="34" charset="-120"/>
               </a:rPr>
-              <a:t>Design: fast 8b, fixed budget (2000), run-lengths {8, 16, 32, 48} (~3k-21k tokens), 3 seeds.</a:t>
-            </a:r>
-            <a:endParaRPr lang="en-US" sz="1300" dirty="0"/>
+              <a:t>No-compaction baseline collapses with length: 0.62 down to 0.12 by 32 sources.</a:t>
+            </a:r>
+            <a:endParaRPr lang="en-US" sz="1250" dirty="0"/>
           </a:p>
           <a:p>
             <a:pPr marL="203200" indent="-203200">
@@ -8315,7 +8261,7 @@
               <a:buChar char="•"/>
             </a:pPr>
             <a:r>
-              <a:rPr lang="en-US" sz="1300" dirty="0">
+              <a:rPr lang="en-US" sz="1250" dirty="0">
                 <a:solidFill>
                   <a:srgbClr val="2E2C32"/>
                 </a:solidFill>
@@ -8323,9 +8269,9 @@
                 <a:ea typeface="Manrope" pitchFamily="34" charset="-122"/>
                 <a:cs typeface="Manrope" pitchFamily="34" charset="-120"/>
               </a:rPr>
-              <a:t>Expectation: baseline recall drops with length; recency stays flatter; they cross.</a:t>
-            </a:r>
-            <a:endParaRPr lang="en-US" sz="1300" dirty="0"/>
+              <a:t>Summary compaction (recency, semantic) holds flat near 0.58.</a:t>
+            </a:r>
+            <a:endParaRPr lang="en-US" sz="1250" dirty="0"/>
           </a:p>
           <a:p>
             <a:pPr marL="203200" indent="-203200">
@@ -8336,7 +8282,7 @@
               <a:buChar char="•"/>
             </a:pPr>
             <a:r>
-              <a:rPr lang="en-US" sz="1100" dirty="0">
+              <a:rPr lang="en-US" sz="1050" dirty="0">
                 <a:solidFill>
                   <a:srgbClr val="655E74"/>
                 </a:solidFill>
@@ -8344,9 +8290,30 @@
                 <a:ea typeface="Manrope" pitchFamily="34" charset="-122"/>
                 <a:cs typeface="Manrope" pitchFamily="34" charset="-120"/>
               </a:rPr>
-              <a:t>Success = a measured crossover point — compaction as recall-positive, not just survival.</a:t>
-            </a:r>
-            <a:endParaRPr lang="en-US" sz="1300" dirty="0"/>
+              <a:t>Crossover around 16 sources: compaction goes from tied to decisively better.</a:t>
+            </a:r>
+            <a:endParaRPr lang="en-US" sz="1250" dirty="0"/>
+          </a:p>
+          <a:p>
+            <a:pPr marL="203200" indent="-203200">
+              <a:spcAft>
+                <a:spcPts val="800"/>
+              </a:spcAft>
+              <a:buSzPct val="100000"/>
+              <a:buChar char="•"/>
+            </a:pPr>
+            <a:r>
+              <a:rPr lang="en-US" sz="1250" dirty="0">
+                <a:solidFill>
+                  <a:srgbClr val="2E2C32"/>
+                </a:solidFill>
+                <a:latin typeface="Manrope" pitchFamily="34" charset="0"/>
+                <a:ea typeface="Manrope" pitchFamily="34" charset="-122"/>
+                <a:cs typeface="Manrope" pitchFamily="34" charset="-120"/>
+              </a:rPr>
+              <a:t>Truncate is the floor (0.08). 8b dev; the effect is the lost-in-the-middle escape.</a:t>
+            </a:r>
+            <a:endParaRPr lang="en-US" sz="1250" dirty="0"/>
           </a:p>
         </p:txBody>
       </p:sp>

</xml_diff>

<commit_message>
Deck: add EXP-003a/003b result slides; add cross-experiment analysis doc
Deck now 27 slides with the applied results (EXP-003a metric-flip + low-pressure tie,
EXP-003b full 7-arm Pareto). Adds docs/research-track/paper/results-so-far.md, a
synthesis of all four experiments (mechanism: EXP-001/002; impact: EXP-003a/b) with
the through-line findings, honest caveats, and next steps.

Co-Authored-By: Claude Opus 4.8 <noreply@anthropic.com>
</commit_message>
<xml_diff>
--- a/presentation/founsi-context-engineering.pptx
+++ b/presentation/founsi-context-engineering.pptx
@@ -30,9 +30,11 @@
     <p:sldId id="278" r:id="rId24"/>
     <p:sldId id="279" r:id="rId25"/>
     <p:sldId id="280" r:id="rId26"/>
+    <p:sldId id="281" r:id="rId27"/>
+    <p:sldId id="282" r:id="rId28"/>
   </p:sldIdLst>
   <p:notesMasterIdLst>
-    <p:notesMasterId r:id="rId27"/>
+    <p:notesMasterId r:id="rId29"/>
   </p:notesMasterIdLst>
   <p:sldSz cx="9144000" cy="5143500"/>
   <p:notesSz cx="5143500" cy="9144000"/>
@@ -2046,6 +2048,182 @@
             <a:fld id="{F7021451-1387-4CA6-816F-3879F97B5CBC}" type="slidenum">
               <a:rPr lang="en-US"/>
               <a:t>25</a:t>
+            </a:fld>
+            <a:endParaRPr lang="en-US"/>
+          </a:p>
+        </p:txBody>
+      </p:sp>
+    </p:spTree>
+    <p:extLst>
+      <p:ext uri="{BB962C8B-B14F-4D97-AF65-F5344CB8AC3E}">
+        <p14:creationId xmlns:p14="http://schemas.microsoft.com/office/powerpoint/2010/main" val="1024086991"/>
+      </p:ext>
+    </p:extLst>
+  </p:cSld>
+  <p:clrMapOvr>
+    <a:masterClrMapping/>
+  </p:clrMapOvr>
+</p:notes>
+</file>
+
+<file path=ppt/notesSlides/notesSlide26.xml><?xml version="1.0" encoding="utf-8"?>
+<p:notes xmlns:a="http://schemas.openxmlformats.org/drawingml/2006/main" xmlns:r="http://schemas.openxmlformats.org/officeDocument/2006/relationships" xmlns:p="http://schemas.openxmlformats.org/presentationml/2006/main">
+  <p:cSld>
+    <p:spTree>
+      <p:nvGrpSpPr>
+        <p:cNvPr id="1" name=""/>
+        <p:cNvGrpSpPr/>
+        <p:nvPr/>
+      </p:nvGrpSpPr>
+      <p:grpSpPr>
+        <a:xfrm>
+          <a:off x="0" y="0"/>
+          <a:ext cx="0" cy="0"/>
+          <a:chOff x="0" y="0"/>
+          <a:chExt cx="0" cy="0"/>
+        </a:xfrm>
+      </p:grpSpPr>
+      <p:sp>
+        <p:nvSpPr>
+          <p:cNvPr id="2" name="Slide Image Placeholder 1"/>
+          <p:cNvSpPr>
+            <a:spLocks noGrp="1" noRot="1" noChangeAspect="1"/>
+          </p:cNvSpPr>
+          <p:nvPr>
+            <p:ph type="sldImg"/>
+          </p:nvPr>
+        </p:nvSpPr>
+        <p:spPr/>
+      </p:sp>
+      <p:sp>
+        <p:nvSpPr>
+          <p:cNvPr id="3" name="Notes Placeholder 2"/>
+          <p:cNvSpPr>
+            <a:spLocks noGrp="1"/>
+          </p:cNvSpPr>
+          <p:nvPr>
+            <p:ph type="body" idx="1"/>
+          </p:nvPr>
+        </p:nvSpPr>
+        <p:spPr/>
+        <p:txBody>
+          <a:bodyPr/>
+          <a:lstStyle/>
+          <a:p>
+            <a:r>
+              <a:rPr lang="en-US" dirty="0"/>
+              <a:t/>
+            </a:r>
+            <a:endParaRPr lang="en-US" dirty="0"/>
+          </a:p>
+        </p:txBody>
+      </p:sp>
+      <p:sp>
+        <p:nvSpPr>
+          <p:cNvPr id="4" name="Slide Number Placeholder 3"/>
+          <p:cNvSpPr>
+            <a:spLocks noGrp="1"/>
+          </p:cNvSpPr>
+          <p:nvPr>
+            <p:ph type="sldNum" sz="quarter" idx="10"/>
+          </p:nvPr>
+        </p:nvSpPr>
+        <p:spPr/>
+        <p:txBody>
+          <a:bodyPr/>
+          <a:lstStyle/>
+          <a:p>
+            <a:fld id="{F7021451-1387-4CA6-816F-3879F97B5CBC}" type="slidenum">
+              <a:rPr lang="en-US"/>
+              <a:t>26</a:t>
+            </a:fld>
+            <a:endParaRPr lang="en-US"/>
+          </a:p>
+        </p:txBody>
+      </p:sp>
+    </p:spTree>
+    <p:extLst>
+      <p:ext uri="{BB962C8B-B14F-4D97-AF65-F5344CB8AC3E}">
+        <p14:creationId xmlns:p14="http://schemas.microsoft.com/office/powerpoint/2010/main" val="1024086991"/>
+      </p:ext>
+    </p:extLst>
+  </p:cSld>
+  <p:clrMapOvr>
+    <a:masterClrMapping/>
+  </p:clrMapOvr>
+</p:notes>
+</file>
+
+<file path=ppt/notesSlides/notesSlide27.xml><?xml version="1.0" encoding="utf-8"?>
+<p:notes xmlns:a="http://schemas.openxmlformats.org/drawingml/2006/main" xmlns:r="http://schemas.openxmlformats.org/officeDocument/2006/relationships" xmlns:p="http://schemas.openxmlformats.org/presentationml/2006/main">
+  <p:cSld>
+    <p:spTree>
+      <p:nvGrpSpPr>
+        <p:cNvPr id="1" name=""/>
+        <p:cNvGrpSpPr/>
+        <p:nvPr/>
+      </p:nvGrpSpPr>
+      <p:grpSpPr>
+        <a:xfrm>
+          <a:off x="0" y="0"/>
+          <a:ext cx="0" cy="0"/>
+          <a:chOff x="0" y="0"/>
+          <a:chExt cx="0" cy="0"/>
+        </a:xfrm>
+      </p:grpSpPr>
+      <p:sp>
+        <p:nvSpPr>
+          <p:cNvPr id="2" name="Slide Image Placeholder 1"/>
+          <p:cNvSpPr>
+            <a:spLocks noGrp="1" noRot="1" noChangeAspect="1"/>
+          </p:cNvSpPr>
+          <p:nvPr>
+            <p:ph type="sldImg"/>
+          </p:nvPr>
+        </p:nvSpPr>
+        <p:spPr/>
+      </p:sp>
+      <p:sp>
+        <p:nvSpPr>
+          <p:cNvPr id="3" name="Notes Placeholder 2"/>
+          <p:cNvSpPr>
+            <a:spLocks noGrp="1"/>
+          </p:cNvSpPr>
+          <p:nvPr>
+            <p:ph type="body" idx="1"/>
+          </p:nvPr>
+        </p:nvSpPr>
+        <p:spPr/>
+        <p:txBody>
+          <a:bodyPr/>
+          <a:lstStyle/>
+          <a:p>
+            <a:r>
+              <a:rPr lang="en-US" dirty="0"/>
+              <a:t/>
+            </a:r>
+            <a:endParaRPr lang="en-US" dirty="0"/>
+          </a:p>
+        </p:txBody>
+      </p:sp>
+      <p:sp>
+        <p:nvSpPr>
+          <p:cNvPr id="4" name="Slide Number Placeholder 3"/>
+          <p:cNvSpPr>
+            <a:spLocks noGrp="1"/>
+          </p:cNvSpPr>
+          <p:nvPr>
+            <p:ph type="sldNum" sz="quarter" idx="10"/>
+          </p:nvPr>
+        </p:nvSpPr>
+        <p:spPr/>
+        <p:txBody>
+          <a:bodyPr/>
+          <a:lstStyle/>
+          <a:p>
+            <a:fld id="{F7021451-1387-4CA6-816F-3879F97B5CBC}" type="slidenum">
+              <a:rPr lang="en-US"/>
+              <a:t>27</a:t>
             </a:fld>
             <a:endParaRPr lang="en-US"/>
           </a:p>
@@ -8382,7 +8560,7 @@
                 <a:ea typeface="Syne" pitchFamily="34" charset="-122"/>
                 <a:cs typeface="Syne" pitchFamily="34" charset="-120"/>
               </a:rPr>
-              <a:t>WHERE THIS GOES</a:t>
+              <a:t>EXP-003A · APPLIED FRAMES</a:t>
             </a:r>
             <a:endParaRPr lang="en-US" sz="1100" dirty="0"/>
           </a:p>
@@ -8413,7 +8591,7 @@
               <a:buNone/>
             </a:pPr>
             <a:r>
-              <a:rPr lang="en-US" sz="2700" b="1" dirty="0">
+              <a:rPr lang="en-US" sz="2300" b="1" dirty="0">
                 <a:solidFill>
                   <a:srgbClr val="2E2C32"/>
                 </a:solidFill>
@@ -8421,9 +8599,9 @@
                 <a:ea typeface="Syne" pitchFamily="34" charset="-122"/>
                 <a:cs typeface="Syne" pitchFamily="34" charset="-120"/>
               </a:rPr>
-              <a:t>Roadmap</a:t>
-            </a:r>
-            <a:endParaRPr lang="en-US" sz="2700" dirty="0"/>
+              <a:t>On a real task, the metric flips the result</a:t>
+            </a:r>
+            <a:endParaRPr lang="en-US" sz="2300" dirty="0"/>
           </a:p>
         </p:txBody>
       </p:sp>
@@ -8543,16 +8721,40 @@
           </a:p>
         </p:txBody>
       </p:sp>
-      <p:sp>
-        <p:nvSpPr>
-          <p:cNvPr id="7" name="Text 4"/>
-          <p:cNvSpPr/>
-          <p:nvPr/>
-        </p:nvSpPr>
-        <p:spPr>
-          <a:xfrm>
-            <a:off x="548640" y="1645920"/>
-            <a:ext cx="8046720" cy="2834640"/>
+      <p:pic>
+        <p:nvPicPr>
+          <p:cNvPr id="7" name="Image 1" descr="/Users/kanishk/Desktop/agent-harness/.claude/worktrees/sleepy-sinoussi-00c73b/presentation/figures/EXP-003a_pareto_v1.png">    </p:cNvPr>
+          <p:cNvPicPr>
+            <a:picLocks noChangeAspect="1"/>
+          </p:cNvPicPr>
+          <p:nvPr/>
+        </p:nvPicPr>
+        <p:blipFill>
+          <a:blip r:embed="rId2"/>
+          <a:stretch>
+            <a:fillRect/>
+          </a:stretch>
+        </p:blipFill>
+        <p:spPr>
+          <a:xfrm>
+            <a:off x="640080" y="1371600"/>
+            <a:ext cx="4846320" cy="3282696"/>
+          </a:xfrm>
+          <a:prstGeom prst="rect">
+            <a:avLst/>
+          </a:prstGeom>
+        </p:spPr>
+      </p:pic>
+      <p:sp>
+        <p:nvSpPr>
+          <p:cNvPr id="8" name="Text 4"/>
+          <p:cNvSpPr/>
+          <p:nvPr/>
+        </p:nvSpPr>
+        <p:spPr>
+          <a:xfrm>
+            <a:off x="5669280" y="1554480"/>
+            <a:ext cx="3017520" cy="2834640"/>
           </a:xfrm>
           <a:prstGeom prst="rect">
             <a:avLst/>
@@ -8572,7 +8774,7 @@
               <a:buChar char="•"/>
             </a:pPr>
             <a:r>
-              <a:rPr lang="en-US" sz="1350" dirty="0">
+              <a:rPr lang="en-US" sz="1250" dirty="0">
                 <a:solidFill>
                   <a:srgbClr val="2E2C32"/>
                 </a:solidFill>
@@ -8580,9 +8782,9 @@
                 <a:ea typeface="Manrope" pitchFamily="34" charset="-122"/>
                 <a:cs typeface="Manrope" pitchFamily="34" charset="-120"/>
               </a:rPr>
-              <a:t>EXP-002 — length degradation (running) · EXP-003 — 70b confirmation, the 128k ceiling.</a:t>
-            </a:r>
-            <a:endParaRPr lang="en-US" sz="1350" dirty="0"/>
+              <a:t>A real research agent answers FRAMES multi-hop questions under each policy.</a:t>
+            </a:r>
+            <a:endParaRPr lang="en-US" sz="1250" dirty="0"/>
           </a:p>
           <a:p>
             <a:pPr marL="203200" indent="-203200">
@@ -8593,7 +8795,7 @@
               <a:buChar char="•"/>
             </a:pPr>
             <a:r>
-              <a:rPr lang="en-US" sz="1350" dirty="0">
+              <a:rPr lang="en-US" sz="1250" dirty="0">
                 <a:solidFill>
                   <a:srgbClr val="2E2C32"/>
                 </a:solidFill>
@@ -8601,9 +8803,9 @@
                 <a:ea typeface="Manrope" pitchFamily="34" charset="-122"/>
                 <a:cs typeface="Manrope" pitchFamily="34" charset="-120"/>
               </a:rPr>
-              <a:t>Lost-in-the-middle: recall by needle depth (data already logged).</a:t>
-            </a:r>
-            <a:endParaRPr lang="en-US" sz="1350" dirty="0"/>
+              <a:t>Substring scoring made the reversible-hybrid look worst, at 0.21.</a:t>
+            </a:r>
+            <a:endParaRPr lang="en-US" sz="1250" dirty="0"/>
           </a:p>
           <a:p>
             <a:pPr marL="203200" indent="-203200">
@@ -8614,17 +8816,17 @@
               <a:buChar char="•"/>
             </a:pPr>
             <a:r>
-              <a:rPr lang="en-US" sz="1350" dirty="0">
-                <a:solidFill>
-                  <a:srgbClr val="2E2C32"/>
+              <a:rPr lang="en-US" sz="1050" dirty="0">
+                <a:solidFill>
+                  <a:srgbClr val="655E74"/>
                 </a:solidFill>
                 <a:latin typeface="Manrope" pitchFamily="34" charset="0"/>
                 <a:ea typeface="Manrope" pitchFamily="34" charset="-122"/>
                 <a:cs typeface="Manrope" pitchFamily="34" charset="-120"/>
               </a:rPr>
-              <a:t>Real eval datasets (RULER / LongBench / BABILong) via HF datasets.</a:t>
-            </a:r>
-            <a:endParaRPr lang="en-US" sz="1350" dirty="0"/>
+              <a:t>The LLM judge, which credits paraphrase, flipped it to best, at 0.62.</a:t>
+            </a:r>
+            <a:endParaRPr lang="en-US" sz="1250" dirty="0"/>
           </a:p>
           <a:p>
             <a:pPr marL="203200" indent="-203200">
@@ -8635,7 +8837,7 @@
               <a:buChar char="•"/>
             </a:pPr>
             <a:r>
-              <a:rPr lang="en-US" sz="1350" dirty="0">
+              <a:rPr lang="en-US" sz="1250" dirty="0">
                 <a:solidFill>
                   <a:srgbClr val="2E2C32"/>
                 </a:solidFill>
@@ -8643,30 +8845,9 @@
                 <a:ea typeface="Manrope" pitchFamily="34" charset="-122"/>
                 <a:cs typeface="Manrope" pitchFamily="34" charset="-120"/>
               </a:rPr>
-              <a:t>LangChain summary-memory as a baseline arm to beat.</a:t>
-            </a:r>
-            <a:endParaRPr lang="en-US" sz="1350" dirty="0"/>
-          </a:p>
-          <a:p>
-            <a:pPr marL="203200" indent="-203200">
-              <a:spcAft>
-                <a:spcPts val="800"/>
-              </a:spcAft>
-              <a:buSzPct val="100000"/>
-              <a:buChar char="•"/>
-            </a:pPr>
-            <a:r>
-              <a:rPr lang="en-US" sz="1350" dirty="0">
-                <a:solidFill>
-                  <a:srgbClr val="2E2C32"/>
-                </a:solidFill>
-                <a:latin typeface="Manrope" pitchFamily="34" charset="0"/>
-                <a:ea typeface="Manrope" pitchFamily="34" charset="-122"/>
-                <a:cs typeface="Manrope" pitchFamily="34" charset="-120"/>
-              </a:rPr>
-              <a:t>Mode B — the live agent loop. Then the paper.</a:t>
-            </a:r>
-            <a:endParaRPr lang="en-US" sz="1350" dirty="0"/>
+              <a:t>At low pressure all four cluster near 0.6: compaction barely fires (~1 event).</a:t>
+            </a:r>
+            <a:endParaRPr lang="en-US" sz="1250" dirty="0"/>
           </a:p>
         </p:txBody>
       </p:sp>
@@ -8735,7 +8916,7 @@
                 <a:ea typeface="Syne" pitchFamily="34" charset="-122"/>
                 <a:cs typeface="Syne" pitchFamily="34" charset="-120"/>
               </a:rPr>
-              <a:t>REFERENCES</a:t>
+              <a:t>EXP-003B · THE COMPACTION BAKE-OFF</a:t>
             </a:r>
             <a:endParaRPr lang="en-US" sz="1100" dirty="0"/>
           </a:p>
@@ -8766,7 +8947,7 @@
               <a:buNone/>
             </a:pPr>
             <a:r>
-              <a:rPr lang="en-US" sz="2600" b="1" dirty="0">
+              <a:rPr lang="en-US" sz="2400" b="1" dirty="0">
                 <a:solidFill>
                   <a:srgbClr val="2E2C32"/>
                 </a:solidFill>
@@ -8774,9 +8955,9 @@
                 <a:ea typeface="Syne" pitchFamily="34" charset="-122"/>
                 <a:cs typeface="Syne" pitchFamily="34" charset="-120"/>
               </a:rPr>
-              <a:t>The literature this stands on</a:t>
-            </a:r>
-            <a:endParaRPr lang="en-US" sz="2600" dirty="0"/>
+              <a:t>Under pressure, the policies separate</a:t>
+            </a:r>
+            <a:endParaRPr lang="en-US" sz="2400" dirty="0"/>
           </a:p>
         </p:txBody>
       </p:sp>
@@ -8896,16 +9077,40 @@
           </a:p>
         </p:txBody>
       </p:sp>
-      <p:sp>
-        <p:nvSpPr>
-          <p:cNvPr id="7" name="Text 4"/>
-          <p:cNvSpPr/>
-          <p:nvPr/>
-        </p:nvSpPr>
-        <p:spPr>
-          <a:xfrm>
-            <a:off x="548640" y="1645920"/>
-            <a:ext cx="8046720" cy="2834640"/>
+      <p:pic>
+        <p:nvPicPr>
+          <p:cNvPr id="7" name="Image 1" descr="/Users/kanishk/Desktop/agent-harness/.claude/worktrees/sleepy-sinoussi-00c73b/presentation/figures/EXP-003b_pareto_v1.png">    </p:cNvPr>
+          <p:cNvPicPr>
+            <a:picLocks noChangeAspect="1"/>
+          </p:cNvPicPr>
+          <p:nvPr/>
+        </p:nvPicPr>
+        <p:blipFill>
+          <a:blip r:embed="rId2"/>
+          <a:stretch>
+            <a:fillRect/>
+          </a:stretch>
+        </p:blipFill>
+        <p:spPr>
+          <a:xfrm>
+            <a:off x="640080" y="1371600"/>
+            <a:ext cx="4846320" cy="3291840"/>
+          </a:xfrm>
+          <a:prstGeom prst="rect">
+            <a:avLst/>
+          </a:prstGeom>
+        </p:spPr>
+      </p:pic>
+      <p:sp>
+        <p:nvSpPr>
+          <p:cNvPr id="8" name="Text 4"/>
+          <p:cNvSpPr/>
+          <p:nvPr/>
+        </p:nvSpPr>
+        <p:spPr>
+          <a:xfrm>
+            <a:off x="5669280" y="1554480"/>
+            <a:ext cx="3017520" cy="2834640"/>
           </a:xfrm>
           <a:prstGeom prst="rect">
             <a:avLst/>
@@ -8925,17 +9130,17 @@
               <a:buChar char="•"/>
             </a:pPr>
             <a:r>
-              <a:rPr lang="en-US" sz="1300" dirty="0">
-                <a:solidFill>
-                  <a:srgbClr val="655E74"/>
+              <a:rPr lang="en-US" sz="1200" dirty="0">
+                <a:solidFill>
+                  <a:srgbClr val="2E2C32"/>
                 </a:solidFill>
                 <a:latin typeface="Manrope" pitchFamily="34" charset="0"/>
                 <a:ea typeface="Manrope" pitchFamily="34" charset="-122"/>
                 <a:cs typeface="Manrope" pitchFamily="34" charset="-120"/>
               </a:rPr>
-              <a:t>Lost in the Middle — Liu et al., arXiv:2307.03172.</a:t>
-            </a:r>
-            <a:endParaRPr lang="en-US" sz="1300" dirty="0"/>
+              <a:t>7 arms, 30 questions, high pressure (9 to 18 compactions each), judged.</a:t>
+            </a:r>
+            <a:endParaRPr lang="en-US" sz="1200" dirty="0"/>
           </a:p>
           <a:p>
             <a:pPr marL="203200" indent="-203200">
@@ -8946,17 +9151,17 @@
               <a:buChar char="•"/>
             </a:pPr>
             <a:r>
-              <a:rPr lang="en-US" sz="1300" dirty="0">
-                <a:solidFill>
-                  <a:srgbClr val="655E74"/>
+              <a:rPr lang="en-US" sz="1200" dirty="0">
+                <a:solidFill>
+                  <a:srgbClr val="2E2C32"/>
                 </a:solidFill>
                 <a:latin typeface="Manrope" pitchFamily="34" charset="0"/>
                 <a:ea typeface="Manrope" pitchFamily="34" charset="-122"/>
                 <a:cs typeface="Manrope" pitchFamily="34" charset="-120"/>
               </a:rPr>
-              <a:t>RULER — Hsieh et al., 2404.06654 · HELMET — Yen et al., 2410.02694.</a:t>
-            </a:r>
-            <a:endParaRPr lang="en-US" sz="1300" dirty="0"/>
+              <a:t>recency, the shipped default, is dominated by truncation: same accuracy, 7x cost.</a:t>
+            </a:r>
+            <a:endParaRPr lang="en-US" sz="1200" dirty="0"/>
           </a:p>
           <a:p>
             <a:pPr marL="203200" indent="-203200">
@@ -8967,17 +9172,17 @@
               <a:buChar char="•"/>
             </a:pPr>
             <a:r>
-              <a:rPr lang="en-US" sz="1300" dirty="0">
-                <a:solidFill>
-                  <a:srgbClr val="655E74"/>
+              <a:rPr lang="en-US" sz="1200" dirty="0">
+                <a:solidFill>
+                  <a:srgbClr val="2E2C32"/>
                 </a:solidFill>
                 <a:latin typeface="Manrope" pitchFamily="34" charset="0"/>
                 <a:ea typeface="Manrope" pitchFamily="34" charset="-122"/>
                 <a:cs typeface="Manrope" pitchFamily="34" charset="-120"/>
               </a:rPr>
-              <a:t>MemGPT — Packer et al., 2310.08560 · LLMLingua — Jiang et al., 2310.05736.</a:t>
-            </a:r>
-            <a:endParaRPr lang="en-US" sz="1300" dirty="0"/>
+              <a:t>sub-agent isolation scores 0.50 at 5x the cost. Isolation is expensive here.</a:t>
+            </a:r>
+            <a:endParaRPr lang="en-US" sz="1200" dirty="0"/>
           </a:p>
           <a:p>
             <a:pPr marL="203200" indent="-203200">
@@ -8988,7 +9193,7 @@
               <a:buChar char="•"/>
             </a:pPr>
             <a:r>
-              <a:rPr lang="en-US" sz="1300" dirty="0">
+              <a:rPr lang="en-US" sz="1000" dirty="0">
                 <a:solidFill>
                   <a:srgbClr val="655E74"/>
                 </a:solidFill>
@@ -8996,30 +9201,9 @@
                 <a:ea typeface="Manrope" pitchFamily="34" charset="-122"/>
                 <a:cs typeface="Manrope" pitchFamily="34" charset="-120"/>
               </a:rPr>
-              <a:t>Judging LLM-as-a-Judge — Zheng et al., 2306.05685.</a:t>
-            </a:r>
-            <a:endParaRPr lang="en-US" sz="1300" dirty="0"/>
-          </a:p>
-          <a:p>
-            <a:pPr marL="203200" indent="-203200">
-              <a:spcAft>
-                <a:spcPts val="800"/>
-              </a:spcAft>
-              <a:buSzPct val="100000"/>
-              <a:buChar char="•"/>
-            </a:pPr>
-            <a:r>
-              <a:rPr lang="en-US" sz="1300" dirty="0">
-                <a:solidFill>
-                  <a:srgbClr val="655E74"/>
-                </a:solidFill>
-                <a:latin typeface="Manrope" pitchFamily="34" charset="0"/>
-                <a:ea typeface="Manrope" pitchFamily="34" charset="-122"/>
-                <a:cs typeface="Manrope" pitchFamily="34" charset="-120"/>
-              </a:rPr>
-              <a:t>Effective context engineering for AI agents — Anthropic, 2025.</a:t>
-            </a:r>
-            <a:endParaRPr lang="en-US" sz="1300" dirty="0"/>
+              <a:t>semantic 0.57 and importance 0.50 lead; reversible-hybrid is on the frontier at 0.47.</a:t>
+            </a:r>
+            <a:endParaRPr lang="en-US" sz="1200" dirty="0"/>
           </a:p>
         </p:txBody>
       </p:sp>
@@ -9034,6 +9218,691 @@
 <file path=ppt/slides/slide25.xml><?xml version="1.0" encoding="utf-8"?>
 <p:sld xmlns:a="http://schemas.openxmlformats.org/drawingml/2006/main" xmlns:r="http://schemas.openxmlformats.org/officeDocument/2006/relationships" xmlns:p="http://schemas.openxmlformats.org/presentationml/2006/main">
   <p:cSld name="Slide 25">
+    <p:bg>
+      <p:bgPr>
+        <a:solidFill>
+          <a:srgbClr val="FAFAFE"/>
+        </a:solidFill>
+      </p:bgPr>
+    </p:bg>
+    <p:spTree>
+      <p:nvGrpSpPr>
+        <p:cNvPr id="1" name=""/>
+        <p:cNvGrpSpPr/>
+        <p:nvPr/>
+      </p:nvGrpSpPr>
+      <p:grpSpPr>
+        <a:xfrm>
+          <a:off x="0" y="0"/>
+          <a:ext cx="0" cy="0"/>
+          <a:chOff x="0" y="0"/>
+          <a:chExt cx="0" cy="0"/>
+        </a:xfrm>
+      </p:grpSpPr>
+      <p:sp>
+        <p:nvSpPr>
+          <p:cNvPr id="2" name="Text 0"/>
+          <p:cNvSpPr/>
+          <p:nvPr/>
+        </p:nvSpPr>
+        <p:spPr>
+          <a:xfrm>
+            <a:off x="548640" y="365760"/>
+            <a:ext cx="8046720" cy="274320"/>
+          </a:xfrm>
+          <a:prstGeom prst="rect">
+            <a:avLst/>
+          </a:prstGeom>
+          <a:noFill/>
+          <a:ln/>
+        </p:spPr>
+        <p:txBody>
+          <a:bodyPr wrap="square" lIns="0" tIns="0" rIns="0" bIns="0" rtlCol="0" anchor="ctr"/>
+          <a:lstStyle/>
+          <a:p>
+            <a:pPr indent="0" marL="0">
+              <a:buNone/>
+            </a:pPr>
+            <a:r>
+              <a:rPr lang="en-US" sz="1100" b="1" spc="300" kern="0" dirty="0">
+                <a:solidFill>
+                  <a:srgbClr val="9378FF"/>
+                </a:solidFill>
+                <a:latin typeface="Syne" pitchFamily="34" charset="0"/>
+                <a:ea typeface="Syne" pitchFamily="34" charset="-122"/>
+                <a:cs typeface="Syne" pitchFamily="34" charset="-120"/>
+              </a:rPr>
+              <a:t>WHERE THIS GOES</a:t>
+            </a:r>
+            <a:endParaRPr lang="en-US" sz="1100" dirty="0"/>
+          </a:p>
+        </p:txBody>
+      </p:sp>
+      <p:sp>
+        <p:nvSpPr>
+          <p:cNvPr id="3" name="Text 1"/>
+          <p:cNvSpPr/>
+          <p:nvPr/>
+        </p:nvSpPr>
+        <p:spPr>
+          <a:xfrm>
+            <a:off x="548640" y="640080"/>
+            <a:ext cx="8046720" cy="868680"/>
+          </a:xfrm>
+          <a:prstGeom prst="rect">
+            <a:avLst/>
+          </a:prstGeom>
+          <a:noFill/>
+          <a:ln/>
+        </p:spPr>
+        <p:txBody>
+          <a:bodyPr wrap="square" lIns="0" tIns="0" rIns="0" bIns="0" rtlCol="0" anchor="t"/>
+          <a:lstStyle/>
+          <a:p>
+            <a:pPr indent="0" marL="0">
+              <a:buNone/>
+            </a:pPr>
+            <a:r>
+              <a:rPr lang="en-US" sz="2500" b="1" dirty="0">
+                <a:solidFill>
+                  <a:srgbClr val="2E2C32"/>
+                </a:solidFill>
+                <a:latin typeface="Syne" pitchFamily="34" charset="0"/>
+                <a:ea typeface="Syne" pitchFamily="34" charset="-122"/>
+                <a:cs typeface="Syne" pitchFamily="34" charset="-120"/>
+              </a:rPr>
+              <a:t>Roadmap</a:t>
+            </a:r>
+            <a:endParaRPr lang="en-US" sz="2500" dirty="0"/>
+          </a:p>
+        </p:txBody>
+      </p:sp>
+      <p:pic>
+        <p:nvPicPr>
+          <p:cNvPr id="4" name="Image 0" descr="preencoded.png">    </p:cNvPr>
+          <p:cNvPicPr>
+            <a:picLocks noChangeAspect="1"/>
+          </p:cNvPicPr>
+          <p:nvPr/>
+        </p:nvPicPr>
+        <p:blipFill>
+          <a:blip r:embed="rId1"/>
+          <a:stretch>
+            <a:fillRect/>
+          </a:stretch>
+        </p:blipFill>
+        <p:spPr>
+          <a:xfrm>
+            <a:off x="548640" y="4736592"/>
+            <a:ext cx="219456" cy="165344"/>
+          </a:xfrm>
+          <a:prstGeom prst="rect">
+            <a:avLst/>
+          </a:prstGeom>
+        </p:spPr>
+      </p:pic>
+      <p:sp>
+        <p:nvSpPr>
+          <p:cNvPr id="5" name="Text 2"/>
+          <p:cNvSpPr/>
+          <p:nvPr/>
+        </p:nvSpPr>
+        <p:spPr>
+          <a:xfrm>
+            <a:off x="822960" y="4690872"/>
+            <a:ext cx="1280160" cy="292608"/>
+          </a:xfrm>
+          <a:prstGeom prst="rect">
+            <a:avLst/>
+          </a:prstGeom>
+          <a:noFill/>
+          <a:ln/>
+        </p:spPr>
+        <p:txBody>
+          <a:bodyPr wrap="square" lIns="0" tIns="0" rIns="0" bIns="0" rtlCol="0" anchor="ctr"/>
+          <a:lstStyle/>
+          <a:p>
+            <a:pPr indent="0" marL="0">
+              <a:buNone/>
+            </a:pPr>
+            <a:r>
+              <a:rPr lang="en-US" sz="1100" b="1" dirty="0">
+                <a:solidFill>
+                  <a:srgbClr val="2E2C32"/>
+                </a:solidFill>
+                <a:latin typeface="Syne" pitchFamily="34" charset="0"/>
+                <a:ea typeface="Syne" pitchFamily="34" charset="-122"/>
+                <a:cs typeface="Syne" pitchFamily="34" charset="-120"/>
+              </a:rPr>
+              <a:t>Founsi</a:t>
+            </a:r>
+            <a:pPr indent="0" marL="0">
+              <a:buNone/>
+            </a:pPr>
+            <a:r>
+              <a:rPr lang="en-US" sz="1100" b="1" dirty="0">
+                <a:solidFill>
+                  <a:srgbClr val="9378FF"/>
+                </a:solidFill>
+                <a:latin typeface="Syne" pitchFamily="34" charset="0"/>
+                <a:ea typeface="Syne" pitchFamily="34" charset="-122"/>
+                <a:cs typeface="Syne" pitchFamily="34" charset="-120"/>
+              </a:rPr>
+              <a:t>.</a:t>
+            </a:r>
+            <a:endParaRPr lang="en-US" sz="1100" dirty="0"/>
+          </a:p>
+        </p:txBody>
+      </p:sp>
+      <p:sp>
+        <p:nvSpPr>
+          <p:cNvPr id="6" name="Text 3"/>
+          <p:cNvSpPr/>
+          <p:nvPr/>
+        </p:nvSpPr>
+        <p:spPr>
+          <a:xfrm>
+            <a:off x="8229600" y="4690872"/>
+            <a:ext cx="365760" cy="292608"/>
+          </a:xfrm>
+          <a:prstGeom prst="rect">
+            <a:avLst/>
+          </a:prstGeom>
+          <a:noFill/>
+          <a:ln/>
+        </p:spPr>
+        <p:txBody>
+          <a:bodyPr wrap="square" lIns="0" tIns="0" rIns="0" bIns="0" rtlCol="0" anchor="ctr"/>
+          <a:lstStyle/>
+          <a:p>
+            <a:pPr algn="r" indent="0" marL="0">
+              <a:buNone/>
+            </a:pPr>
+            <a:r>
+              <a:rPr lang="en-US" sz="900" dirty="0">
+                <a:solidFill>
+                  <a:srgbClr val="7E7A8A"/>
+                </a:solidFill>
+                <a:latin typeface="Manrope" pitchFamily="34" charset="0"/>
+                <a:ea typeface="Manrope" pitchFamily="34" charset="-122"/>
+                <a:cs typeface="Manrope" pitchFamily="34" charset="-120"/>
+              </a:rPr>
+              <a:t>25</a:t>
+            </a:r>
+            <a:endParaRPr lang="en-US" sz="900" dirty="0"/>
+          </a:p>
+        </p:txBody>
+      </p:sp>
+      <p:sp>
+        <p:nvSpPr>
+          <p:cNvPr id="7" name="Text 4"/>
+          <p:cNvSpPr/>
+          <p:nvPr/>
+        </p:nvSpPr>
+        <p:spPr>
+          <a:xfrm>
+            <a:off x="548640" y="1645920"/>
+            <a:ext cx="8046720" cy="2834640"/>
+          </a:xfrm>
+          <a:prstGeom prst="rect">
+            <a:avLst/>
+          </a:prstGeom>
+          <a:noFill/>
+          <a:ln/>
+        </p:spPr>
+        <p:txBody>
+          <a:bodyPr wrap="square" rtlCol="0" anchor="ctr"/>
+          <a:lstStyle/>
+          <a:p>
+            <a:pPr marL="203200" indent="-203200">
+              <a:spcAft>
+                <a:spcPts val="800"/>
+              </a:spcAft>
+              <a:buSzPct val="100000"/>
+              <a:buChar char="•"/>
+            </a:pPr>
+            <a:r>
+              <a:rPr lang="en-US" sz="1350" dirty="0">
+                <a:solidFill>
+                  <a:srgbClr val="2E2C32"/>
+                </a:solidFill>
+                <a:latin typeface="Manrope" pitchFamily="34" charset="0"/>
+                <a:ea typeface="Manrope" pitchFamily="34" charset="-122"/>
+                <a:cs typeface="Manrope" pitchFamily="34" charset="-120"/>
+              </a:rPr>
+              <a:t>EXP-003c: the 70b model and the reasoning model (the model-dependence map).</a:t>
+            </a:r>
+            <a:endParaRPr lang="en-US" sz="1350" dirty="0"/>
+          </a:p>
+          <a:p>
+            <a:pPr marL="203200" indent="-203200">
+              <a:spcAft>
+                <a:spcPts val="800"/>
+              </a:spcAft>
+              <a:buSzPct val="100000"/>
+              <a:buChar char="•"/>
+            </a:pPr>
+            <a:r>
+              <a:rPr lang="en-US" sz="1350" dirty="0">
+                <a:solidFill>
+                  <a:srgbClr val="2E2C32"/>
+                </a:solidFill>
+                <a:latin typeface="Manrope" pitchFamily="34" charset="0"/>
+                <a:ea typeface="Manrope" pitchFamily="34" charset="-122"/>
+                <a:cs typeface="Manrope" pitchFamily="34" charset="-120"/>
+              </a:rPr>
+              <a:t>EXP-004: LoCoMo conversational memory, the second domain.</a:t>
+            </a:r>
+            <a:endParaRPr lang="en-US" sz="1350" dirty="0"/>
+          </a:p>
+          <a:p>
+            <a:pPr marL="203200" indent="-203200">
+              <a:spcAft>
+                <a:spcPts val="800"/>
+              </a:spcAft>
+              <a:buSzPct val="100000"/>
+              <a:buChar char="•"/>
+            </a:pPr>
+            <a:r>
+              <a:rPr lang="en-US" sz="1350" dirty="0">
+                <a:solidFill>
+                  <a:srgbClr val="2E2C32"/>
+                </a:solidFill>
+                <a:latin typeface="Manrope" pitchFamily="34" charset="0"/>
+                <a:ea typeface="Manrope" pitchFamily="34" charset="-122"/>
+                <a:cs typeface="Manrope" pitchFamily="34" charset="-120"/>
+              </a:rPr>
+              <a:t>Larger N and tighter error bars on the arms that separate.</a:t>
+            </a:r>
+            <a:endParaRPr lang="en-US" sz="1350" dirty="0"/>
+          </a:p>
+          <a:p>
+            <a:pPr marL="203200" indent="-203200">
+              <a:spcAft>
+                <a:spcPts val="800"/>
+              </a:spcAft>
+              <a:buSzPct val="100000"/>
+              <a:buChar char="•"/>
+            </a:pPr>
+            <a:r>
+              <a:rPr lang="en-US" sz="1350" dirty="0">
+                <a:solidFill>
+                  <a:srgbClr val="2E2C32"/>
+                </a:solidFill>
+                <a:latin typeface="Manrope" pitchFamily="34" charset="0"/>
+                <a:ea typeface="Manrope" pitchFamily="34" charset="-122"/>
+                <a:cs typeface="Manrope" pitchFamily="34" charset="-120"/>
+              </a:rPr>
+              <a:t>LangChain summary-memory as a baseline arm; then the paper.</a:t>
+            </a:r>
+            <a:endParaRPr lang="en-US" sz="1350" dirty="0"/>
+          </a:p>
+        </p:txBody>
+      </p:sp>
+    </p:spTree>
+  </p:cSld>
+  <p:clrMapOvr>
+    <a:masterClrMapping/>
+  </p:clrMapOvr>
+</p:sld>
+</file>
+
+<file path=ppt/slides/slide26.xml><?xml version="1.0" encoding="utf-8"?>
+<p:sld xmlns:a="http://schemas.openxmlformats.org/drawingml/2006/main" xmlns:r="http://schemas.openxmlformats.org/officeDocument/2006/relationships" xmlns:p="http://schemas.openxmlformats.org/presentationml/2006/main">
+  <p:cSld name="Slide 26">
+    <p:bg>
+      <p:bgPr>
+        <a:solidFill>
+          <a:srgbClr val="FAFAFE"/>
+        </a:solidFill>
+      </p:bgPr>
+    </p:bg>
+    <p:spTree>
+      <p:nvGrpSpPr>
+        <p:cNvPr id="1" name=""/>
+        <p:cNvGrpSpPr/>
+        <p:nvPr/>
+      </p:nvGrpSpPr>
+      <p:grpSpPr>
+        <a:xfrm>
+          <a:off x="0" y="0"/>
+          <a:ext cx="0" cy="0"/>
+          <a:chOff x="0" y="0"/>
+          <a:chExt cx="0" cy="0"/>
+        </a:xfrm>
+      </p:grpSpPr>
+      <p:sp>
+        <p:nvSpPr>
+          <p:cNvPr id="2" name="Text 0"/>
+          <p:cNvSpPr/>
+          <p:nvPr/>
+        </p:nvSpPr>
+        <p:spPr>
+          <a:xfrm>
+            <a:off x="548640" y="365760"/>
+            <a:ext cx="8046720" cy="274320"/>
+          </a:xfrm>
+          <a:prstGeom prst="rect">
+            <a:avLst/>
+          </a:prstGeom>
+          <a:noFill/>
+          <a:ln/>
+        </p:spPr>
+        <p:txBody>
+          <a:bodyPr wrap="square" lIns="0" tIns="0" rIns="0" bIns="0" rtlCol="0" anchor="ctr"/>
+          <a:lstStyle/>
+          <a:p>
+            <a:pPr indent="0" marL="0">
+              <a:buNone/>
+            </a:pPr>
+            <a:r>
+              <a:rPr lang="en-US" sz="1100" b="1" spc="300" kern="0" dirty="0">
+                <a:solidFill>
+                  <a:srgbClr val="9378FF"/>
+                </a:solidFill>
+                <a:latin typeface="Syne" pitchFamily="34" charset="0"/>
+                <a:ea typeface="Syne" pitchFamily="34" charset="-122"/>
+                <a:cs typeface="Syne" pitchFamily="34" charset="-120"/>
+              </a:rPr>
+              <a:t>REFERENCES</a:t>
+            </a:r>
+            <a:endParaRPr lang="en-US" sz="1100" dirty="0"/>
+          </a:p>
+        </p:txBody>
+      </p:sp>
+      <p:sp>
+        <p:nvSpPr>
+          <p:cNvPr id="3" name="Text 1"/>
+          <p:cNvSpPr/>
+          <p:nvPr/>
+        </p:nvSpPr>
+        <p:spPr>
+          <a:xfrm>
+            <a:off x="548640" y="640080"/>
+            <a:ext cx="8046720" cy="868680"/>
+          </a:xfrm>
+          <a:prstGeom prst="rect">
+            <a:avLst/>
+          </a:prstGeom>
+          <a:noFill/>
+          <a:ln/>
+        </p:spPr>
+        <p:txBody>
+          <a:bodyPr wrap="square" lIns="0" tIns="0" rIns="0" bIns="0" rtlCol="0" anchor="t"/>
+          <a:lstStyle/>
+          <a:p>
+            <a:pPr indent="0" marL="0">
+              <a:buNone/>
+            </a:pPr>
+            <a:r>
+              <a:rPr lang="en-US" sz="2600" b="1" dirty="0">
+                <a:solidFill>
+                  <a:srgbClr val="2E2C32"/>
+                </a:solidFill>
+                <a:latin typeface="Syne" pitchFamily="34" charset="0"/>
+                <a:ea typeface="Syne" pitchFamily="34" charset="-122"/>
+                <a:cs typeface="Syne" pitchFamily="34" charset="-120"/>
+              </a:rPr>
+              <a:t>The literature this stands on</a:t>
+            </a:r>
+            <a:endParaRPr lang="en-US" sz="2600" dirty="0"/>
+          </a:p>
+        </p:txBody>
+      </p:sp>
+      <p:pic>
+        <p:nvPicPr>
+          <p:cNvPr id="4" name="Image 0" descr="preencoded.png">    </p:cNvPr>
+          <p:cNvPicPr>
+            <a:picLocks noChangeAspect="1"/>
+          </p:cNvPicPr>
+          <p:nvPr/>
+        </p:nvPicPr>
+        <p:blipFill>
+          <a:blip r:embed="rId1"/>
+          <a:stretch>
+            <a:fillRect/>
+          </a:stretch>
+        </p:blipFill>
+        <p:spPr>
+          <a:xfrm>
+            <a:off x="548640" y="4736592"/>
+            <a:ext cx="219456" cy="165344"/>
+          </a:xfrm>
+          <a:prstGeom prst="rect">
+            <a:avLst/>
+          </a:prstGeom>
+        </p:spPr>
+      </p:pic>
+      <p:sp>
+        <p:nvSpPr>
+          <p:cNvPr id="5" name="Text 2"/>
+          <p:cNvSpPr/>
+          <p:nvPr/>
+        </p:nvSpPr>
+        <p:spPr>
+          <a:xfrm>
+            <a:off x="822960" y="4690872"/>
+            <a:ext cx="1280160" cy="292608"/>
+          </a:xfrm>
+          <a:prstGeom prst="rect">
+            <a:avLst/>
+          </a:prstGeom>
+          <a:noFill/>
+          <a:ln/>
+        </p:spPr>
+        <p:txBody>
+          <a:bodyPr wrap="square" lIns="0" tIns="0" rIns="0" bIns="0" rtlCol="0" anchor="ctr"/>
+          <a:lstStyle/>
+          <a:p>
+            <a:pPr indent="0" marL="0">
+              <a:buNone/>
+            </a:pPr>
+            <a:r>
+              <a:rPr lang="en-US" sz="1100" b="1" dirty="0">
+                <a:solidFill>
+                  <a:srgbClr val="2E2C32"/>
+                </a:solidFill>
+                <a:latin typeface="Syne" pitchFamily="34" charset="0"/>
+                <a:ea typeface="Syne" pitchFamily="34" charset="-122"/>
+                <a:cs typeface="Syne" pitchFamily="34" charset="-120"/>
+              </a:rPr>
+              <a:t>Founsi</a:t>
+            </a:r>
+            <a:pPr indent="0" marL="0">
+              <a:buNone/>
+            </a:pPr>
+            <a:r>
+              <a:rPr lang="en-US" sz="1100" b="1" dirty="0">
+                <a:solidFill>
+                  <a:srgbClr val="9378FF"/>
+                </a:solidFill>
+                <a:latin typeface="Syne" pitchFamily="34" charset="0"/>
+                <a:ea typeface="Syne" pitchFamily="34" charset="-122"/>
+                <a:cs typeface="Syne" pitchFamily="34" charset="-120"/>
+              </a:rPr>
+              <a:t>.</a:t>
+            </a:r>
+            <a:endParaRPr lang="en-US" sz="1100" dirty="0"/>
+          </a:p>
+        </p:txBody>
+      </p:sp>
+      <p:sp>
+        <p:nvSpPr>
+          <p:cNvPr id="6" name="Text 3"/>
+          <p:cNvSpPr/>
+          <p:nvPr/>
+        </p:nvSpPr>
+        <p:spPr>
+          <a:xfrm>
+            <a:off x="8229600" y="4690872"/>
+            <a:ext cx="365760" cy="292608"/>
+          </a:xfrm>
+          <a:prstGeom prst="rect">
+            <a:avLst/>
+          </a:prstGeom>
+          <a:noFill/>
+          <a:ln/>
+        </p:spPr>
+        <p:txBody>
+          <a:bodyPr wrap="square" lIns="0" tIns="0" rIns="0" bIns="0" rtlCol="0" anchor="ctr"/>
+          <a:lstStyle/>
+          <a:p>
+            <a:pPr algn="r" indent="0" marL="0">
+              <a:buNone/>
+            </a:pPr>
+            <a:r>
+              <a:rPr lang="en-US" sz="900" dirty="0">
+                <a:solidFill>
+                  <a:srgbClr val="7E7A8A"/>
+                </a:solidFill>
+                <a:latin typeface="Manrope" pitchFamily="34" charset="0"/>
+                <a:ea typeface="Manrope" pitchFamily="34" charset="-122"/>
+                <a:cs typeface="Manrope" pitchFamily="34" charset="-120"/>
+              </a:rPr>
+              <a:t>26</a:t>
+            </a:r>
+            <a:endParaRPr lang="en-US" sz="900" dirty="0"/>
+          </a:p>
+        </p:txBody>
+      </p:sp>
+      <p:sp>
+        <p:nvSpPr>
+          <p:cNvPr id="7" name="Text 4"/>
+          <p:cNvSpPr/>
+          <p:nvPr/>
+        </p:nvSpPr>
+        <p:spPr>
+          <a:xfrm>
+            <a:off x="548640" y="1645920"/>
+            <a:ext cx="8046720" cy="2834640"/>
+          </a:xfrm>
+          <a:prstGeom prst="rect">
+            <a:avLst/>
+          </a:prstGeom>
+          <a:noFill/>
+          <a:ln/>
+        </p:spPr>
+        <p:txBody>
+          <a:bodyPr wrap="square" rtlCol="0" anchor="ctr"/>
+          <a:lstStyle/>
+          <a:p>
+            <a:pPr marL="203200" indent="-203200">
+              <a:spcAft>
+                <a:spcPts val="800"/>
+              </a:spcAft>
+              <a:buSzPct val="100000"/>
+              <a:buChar char="•"/>
+            </a:pPr>
+            <a:r>
+              <a:rPr lang="en-US" sz="1300" dirty="0">
+                <a:solidFill>
+                  <a:srgbClr val="655E74"/>
+                </a:solidFill>
+                <a:latin typeface="Manrope" pitchFamily="34" charset="0"/>
+                <a:ea typeface="Manrope" pitchFamily="34" charset="-122"/>
+                <a:cs typeface="Manrope" pitchFamily="34" charset="-120"/>
+              </a:rPr>
+              <a:t>Lost in the Middle, Liu et al., arXiv:2307.03172.</a:t>
+            </a:r>
+            <a:endParaRPr lang="en-US" sz="1300" dirty="0"/>
+          </a:p>
+          <a:p>
+            <a:pPr marL="203200" indent="-203200">
+              <a:spcAft>
+                <a:spcPts val="800"/>
+              </a:spcAft>
+              <a:buSzPct val="100000"/>
+              <a:buChar char="•"/>
+            </a:pPr>
+            <a:r>
+              <a:rPr lang="en-US" sz="1300" dirty="0">
+                <a:solidFill>
+                  <a:srgbClr val="655E74"/>
+                </a:solidFill>
+                <a:latin typeface="Manrope" pitchFamily="34" charset="0"/>
+                <a:ea typeface="Manrope" pitchFamily="34" charset="-122"/>
+                <a:cs typeface="Manrope" pitchFamily="34" charset="-120"/>
+              </a:rPr>
+              <a:t>RULER 2404.06654 · HELMET 2410.02694 · NoLiMa 2502.05167.</a:t>
+            </a:r>
+            <a:endParaRPr lang="en-US" sz="1300" dirty="0"/>
+          </a:p>
+          <a:p>
+            <a:pPr marL="203200" indent="-203200">
+              <a:spcAft>
+                <a:spcPts val="800"/>
+              </a:spcAft>
+              <a:buSzPct val="100000"/>
+              <a:buChar char="•"/>
+            </a:pPr>
+            <a:r>
+              <a:rPr lang="en-US" sz="1300" dirty="0">
+                <a:solidFill>
+                  <a:srgbClr val="655E74"/>
+                </a:solidFill>
+                <a:latin typeface="Manrope" pitchFamily="34" charset="0"/>
+                <a:ea typeface="Manrope" pitchFamily="34" charset="-122"/>
+                <a:cs typeface="Manrope" pitchFamily="34" charset="-120"/>
+              </a:rPr>
+              <a:t>MemGPT 2310.08560 · Mem0 2504.19413 · ACON 2510.00615.</a:t>
+            </a:r>
+            <a:endParaRPr lang="en-US" sz="1300" dirty="0"/>
+          </a:p>
+          <a:p>
+            <a:pPr marL="203200" indent="-203200">
+              <a:spcAft>
+                <a:spcPts val="800"/>
+              </a:spcAft>
+              <a:buSzPct val="100000"/>
+              <a:buChar char="•"/>
+            </a:pPr>
+            <a:r>
+              <a:rPr lang="en-US" sz="1300" dirty="0">
+                <a:solidFill>
+                  <a:srgbClr val="655E74"/>
+                </a:solidFill>
+                <a:latin typeface="Manrope" pitchFamily="34" charset="0"/>
+                <a:ea typeface="Manrope" pitchFamily="34" charset="-122"/>
+                <a:cs typeface="Manrope" pitchFamily="34" charset="-120"/>
+              </a:rPr>
+              <a:t>Judging LLM-as-a-Judge, Zheng et al., 2306.05685.</a:t>
+            </a:r>
+            <a:endParaRPr lang="en-US" sz="1300" dirty="0"/>
+          </a:p>
+          <a:p>
+            <a:pPr marL="203200" indent="-203200">
+              <a:spcAft>
+                <a:spcPts val="800"/>
+              </a:spcAft>
+              <a:buSzPct val="100000"/>
+              <a:buChar char="•"/>
+            </a:pPr>
+            <a:r>
+              <a:rPr lang="en-US" sz="1300" dirty="0">
+                <a:solidFill>
+                  <a:srgbClr val="655E74"/>
+                </a:solidFill>
+                <a:latin typeface="Manrope" pitchFamily="34" charset="0"/>
+                <a:ea typeface="Manrope" pitchFamily="34" charset="-122"/>
+                <a:cs typeface="Manrope" pitchFamily="34" charset="-120"/>
+              </a:rPr>
+              <a:t>FRAMES 2409.12941 · LoCoMo 2402.17753.</a:t>
+            </a:r>
+            <a:endParaRPr lang="en-US" sz="1300" dirty="0"/>
+          </a:p>
+        </p:txBody>
+      </p:sp>
+    </p:spTree>
+  </p:cSld>
+  <p:clrMapOvr>
+    <a:masterClrMapping/>
+  </p:clrMapOvr>
+</p:sld>
+</file>
+
+<file path=ppt/slides/slide27.xml><?xml version="1.0" encoding="utf-8"?>
+<p:sld xmlns:a="http://schemas.openxmlformats.org/drawingml/2006/main" xmlns:r="http://schemas.openxmlformats.org/officeDocument/2006/relationships" xmlns:p="http://schemas.openxmlformats.org/presentationml/2006/main">
+  <p:cSld name="Slide 27">
     <p:bg>
       <p:bgPr>
         <a:solidFill>
@@ -9495,7 +10364,7 @@
                 <a:ea typeface="Manrope" pitchFamily="34" charset="-122"/>
                 <a:cs typeface="Manrope" pitchFamily="34" charset="-120"/>
               </a:rPr>
-              <a:t>25</a:t>
+              <a:t>27</a:t>
             </a:r>
             <a:endParaRPr lang="en-US" sz="900" dirty="0"/>
           </a:p>

</xml_diff>

<commit_message>
Deck: add EXP-003c model-axis slide (28 slides)
Slide 25 presents the completed model axis: the EXP-003c_modelaxis_v1 figure plus the
finding that blind truncation stays at the floor across 8B/70B/reasoning while every
structure/retrieval arm climbs, so the smart-vs-blind gap widens with capability.
Roadmap updated (EXP-003c done), references and find-me renumbered to 27/28.

Co-Authored-By: Claude Opus 4.8 <noreply@anthropic.com>
</commit_message>
<xml_diff>
--- a/presentation/founsi-context-engineering.pptx
+++ b/presentation/founsi-context-engineering.pptx
@@ -32,9 +32,10 @@
     <p:sldId id="280" r:id="rId26"/>
     <p:sldId id="281" r:id="rId27"/>
     <p:sldId id="282" r:id="rId28"/>
+    <p:sldId id="283" r:id="rId29"/>
   </p:sldIdLst>
   <p:notesMasterIdLst>
-    <p:notesMasterId r:id="rId29"/>
+    <p:notesMasterId r:id="rId30"/>
   </p:notesMasterIdLst>
   <p:sldSz cx="9144000" cy="5143500"/>
   <p:notesSz cx="5143500" cy="9144000"/>
@@ -2224,6 +2225,94 @@
             <a:fld id="{F7021451-1387-4CA6-816F-3879F97B5CBC}" type="slidenum">
               <a:rPr lang="en-US"/>
               <a:t>27</a:t>
+            </a:fld>
+            <a:endParaRPr lang="en-US"/>
+          </a:p>
+        </p:txBody>
+      </p:sp>
+    </p:spTree>
+    <p:extLst>
+      <p:ext uri="{BB962C8B-B14F-4D97-AF65-F5344CB8AC3E}">
+        <p14:creationId xmlns:p14="http://schemas.microsoft.com/office/powerpoint/2010/main" val="1024086991"/>
+      </p:ext>
+    </p:extLst>
+  </p:cSld>
+  <p:clrMapOvr>
+    <a:masterClrMapping/>
+  </p:clrMapOvr>
+</p:notes>
+</file>
+
+<file path=ppt/notesSlides/notesSlide28.xml><?xml version="1.0" encoding="utf-8"?>
+<p:notes xmlns:a="http://schemas.openxmlformats.org/drawingml/2006/main" xmlns:r="http://schemas.openxmlformats.org/officeDocument/2006/relationships" xmlns:p="http://schemas.openxmlformats.org/presentationml/2006/main">
+  <p:cSld>
+    <p:spTree>
+      <p:nvGrpSpPr>
+        <p:cNvPr id="1" name=""/>
+        <p:cNvGrpSpPr/>
+        <p:nvPr/>
+      </p:nvGrpSpPr>
+      <p:grpSpPr>
+        <a:xfrm>
+          <a:off x="0" y="0"/>
+          <a:ext cx="0" cy="0"/>
+          <a:chOff x="0" y="0"/>
+          <a:chExt cx="0" cy="0"/>
+        </a:xfrm>
+      </p:grpSpPr>
+      <p:sp>
+        <p:nvSpPr>
+          <p:cNvPr id="2" name="Slide Image Placeholder 1"/>
+          <p:cNvSpPr>
+            <a:spLocks noGrp="1" noRot="1" noChangeAspect="1"/>
+          </p:cNvSpPr>
+          <p:nvPr>
+            <p:ph type="sldImg"/>
+          </p:nvPr>
+        </p:nvSpPr>
+        <p:spPr/>
+      </p:sp>
+      <p:sp>
+        <p:nvSpPr>
+          <p:cNvPr id="3" name="Notes Placeholder 2"/>
+          <p:cNvSpPr>
+            <a:spLocks noGrp="1"/>
+          </p:cNvSpPr>
+          <p:nvPr>
+            <p:ph type="body" idx="1"/>
+          </p:nvPr>
+        </p:nvSpPr>
+        <p:spPr/>
+        <p:txBody>
+          <a:bodyPr/>
+          <a:lstStyle/>
+          <a:p>
+            <a:r>
+              <a:rPr lang="en-US" dirty="0"/>
+              <a:t/>
+            </a:r>
+            <a:endParaRPr lang="en-US" dirty="0"/>
+          </a:p>
+        </p:txBody>
+      </p:sp>
+      <p:sp>
+        <p:nvSpPr>
+          <p:cNvPr id="4" name="Slide Number Placeholder 3"/>
+          <p:cNvSpPr>
+            <a:spLocks noGrp="1"/>
+          </p:cNvSpPr>
+          <p:nvPr>
+            <p:ph type="sldNum" sz="quarter" idx="10"/>
+          </p:nvPr>
+        </p:nvSpPr>
+        <p:spPr/>
+        <p:txBody>
+          <a:bodyPr/>
+          <a:lstStyle/>
+          <a:p>
+            <a:fld id="{F7021451-1387-4CA6-816F-3879F97B5CBC}" type="slidenum">
+              <a:rPr lang="en-US"/>
+              <a:t>28</a:t>
             </a:fld>
             <a:endParaRPr lang="en-US"/>
           </a:p>
@@ -9272,7 +9361,7 @@
                 <a:ea typeface="Syne" pitchFamily="34" charset="-122"/>
                 <a:cs typeface="Syne" pitchFamily="34" charset="-120"/>
               </a:rPr>
-              <a:t>WHERE THIS GOES</a:t>
+              <a:t>EXP-003C · THE MODEL AXIS</a:t>
             </a:r>
             <a:endParaRPr lang="en-US" sz="1100" dirty="0"/>
           </a:p>
@@ -9311,7 +9400,7 @@
                 <a:ea typeface="Syne" pitchFamily="34" charset="-122"/>
                 <a:cs typeface="Syne" pitchFamily="34" charset="-120"/>
               </a:rPr>
-              <a:t>Roadmap</a:t>
+              <a:t>Stronger models widen the smart-vs-blind gap</a:t>
             </a:r>
             <a:endParaRPr lang="en-US" sz="2500" dirty="0"/>
           </a:p>
@@ -9433,16 +9522,40 @@
           </a:p>
         </p:txBody>
       </p:sp>
-      <p:sp>
-        <p:nvSpPr>
-          <p:cNvPr id="7" name="Text 4"/>
-          <p:cNvSpPr/>
-          <p:nvPr/>
-        </p:nvSpPr>
-        <p:spPr>
-          <a:xfrm>
-            <a:off x="548640" y="1645920"/>
-            <a:ext cx="8046720" cy="2834640"/>
+      <p:pic>
+        <p:nvPicPr>
+          <p:cNvPr id="7" name="Image 1" descr="/Users/kanishk/Desktop/agent-harness/.claude/worktrees/sleepy-sinoussi-00c73b/presentation/figures/EXP-003c_modelaxis_v1.png">    </p:cNvPr>
+          <p:cNvPicPr>
+            <a:picLocks noChangeAspect="1"/>
+          </p:cNvPicPr>
+          <p:nvPr/>
+        </p:nvPicPr>
+        <p:blipFill>
+          <a:blip r:embed="rId2"/>
+          <a:stretch>
+            <a:fillRect/>
+          </a:stretch>
+        </p:blipFill>
+        <p:spPr>
+          <a:xfrm>
+            <a:off x="640080" y="1371600"/>
+            <a:ext cx="4846320" cy="3200400"/>
+          </a:xfrm>
+          <a:prstGeom prst="rect">
+            <a:avLst/>
+          </a:prstGeom>
+        </p:spPr>
+      </p:pic>
+      <p:sp>
+        <p:nvSpPr>
+          <p:cNvPr id="8" name="Text 4"/>
+          <p:cNvSpPr/>
+          <p:nvPr/>
+        </p:nvSpPr>
+        <p:spPr>
+          <a:xfrm>
+            <a:off x="5669280" y="1554480"/>
+            <a:ext cx="3017520" cy="2834640"/>
           </a:xfrm>
           <a:prstGeom prst="rect">
             <a:avLst/>
@@ -9462,7 +9575,7 @@
               <a:buChar char="•"/>
             </a:pPr>
             <a:r>
-              <a:rPr lang="en-US" sz="1350" dirty="0">
+              <a:rPr lang="en-US" sz="1200" dirty="0">
                 <a:solidFill>
                   <a:srgbClr val="2E2C32"/>
                 </a:solidFill>
@@ -9470,9 +9583,9 @@
                 <a:ea typeface="Manrope" pitchFamily="34" charset="-122"/>
                 <a:cs typeface="Manrope" pitchFamily="34" charset="-120"/>
               </a:rPr>
-              <a:t>EXP-003c: the 70b model and the reasoning model (the model-dependence map).</a:t>
-            </a:r>
-            <a:endParaRPr lang="en-US" sz="1350" dirty="0"/>
+              <a:t>5 arms across 3 agent models: 8B, 70B, and a reasoning model. Judge held at 70B.</a:t>
+            </a:r>
+            <a:endParaRPr lang="en-US" sz="1200" dirty="0"/>
           </a:p>
           <a:p>
             <a:pPr marL="203200" indent="-203200">
@@ -9483,7 +9596,7 @@
               <a:buChar char="•"/>
             </a:pPr>
             <a:r>
-              <a:rPr lang="en-US" sz="1350" dirty="0">
+              <a:rPr lang="en-US" sz="1200" dirty="0">
                 <a:solidFill>
                   <a:srgbClr val="2E2C32"/>
                 </a:solidFill>
@@ -9491,9 +9604,9 @@
                 <a:ea typeface="Manrope" pitchFamily="34" charset="-122"/>
                 <a:cs typeface="Manrope" pitchFamily="34" charset="-120"/>
               </a:rPr>
-              <a:t>EXP-004: LoCoMo conversational memory, the second domain.</a:t>
-            </a:r>
-            <a:endParaRPr lang="en-US" sz="1350" dirty="0"/>
+              <a:t>Blind truncation never improves: 0.37, 0.27, 0.40 — a better model can't recover dropped context.</a:t>
+            </a:r>
+            <a:endParaRPr lang="en-US" sz="1200" dirty="0"/>
           </a:p>
           <a:p>
             <a:pPr marL="203200" indent="-203200">
@@ -9504,7 +9617,7 @@
               <a:buChar char="•"/>
             </a:pPr>
             <a:r>
-              <a:rPr lang="en-US" sz="1350" dirty="0">
+              <a:rPr lang="en-US" sz="1200" dirty="0">
                 <a:solidFill>
                   <a:srgbClr val="2E2C32"/>
                 </a:solidFill>
@@ -9512,9 +9625,9 @@
                 <a:ea typeface="Manrope" pitchFamily="34" charset="-122"/>
                 <a:cs typeface="Manrope" pitchFamily="34" charset="-120"/>
               </a:rPr>
-              <a:t>Larger N and tighter error bars on the arms that separate.</a:t>
-            </a:r>
-            <a:endParaRPr lang="en-US" sz="1350" dirty="0"/>
+              <a:t>Every structure or retrieval arm climbs; the gap to truncation grows from ~0.2 to ~0.3.</a:t>
+            </a:r>
+            <a:endParaRPr lang="en-US" sz="1200" dirty="0"/>
           </a:p>
           <a:p>
             <a:pPr marL="203200" indent="-203200">
@@ -9525,17 +9638,17 @@
               <a:buChar char="•"/>
             </a:pPr>
             <a:r>
-              <a:rPr lang="en-US" sz="1350" dirty="0">
-                <a:solidFill>
-                  <a:srgbClr val="2E2C32"/>
-                </a:solidFill>
-                <a:latin typeface="Manrope" pitchFamily="34" charset="0"/>
-                <a:ea typeface="Manrope" pitchFamily="34" charset="-122"/>
-                <a:cs typeface="Manrope" pitchFamily="34" charset="-120"/>
-              </a:rPr>
-              <a:t>LangChain summary-memory as a baseline arm; then the paper.</a:t>
-            </a:r>
-            <a:endParaRPr lang="en-US" sz="1350" dirty="0"/>
+              <a:rPr lang="en-US" sz="1000" dirty="0">
+                <a:solidFill>
+                  <a:srgbClr val="655E74"/>
+                </a:solidFill>
+                <a:latin typeface="Manrope" pitchFamily="34" charset="0"/>
+                <a:ea typeface="Manrope" pitchFamily="34" charset="-122"/>
+                <a:cs typeface="Manrope" pitchFamily="34" charset="-120"/>
+              </a:rPr>
+              <a:t>On the reasoning model, importance and our reversible-hybrid lead at 0.70.</a:t>
+            </a:r>
+            <a:endParaRPr lang="en-US" sz="1200" dirty="0"/>
           </a:p>
         </p:txBody>
       </p:sp>
@@ -9604,7 +9717,7 @@
                 <a:ea typeface="Syne" pitchFamily="34" charset="-122"/>
                 <a:cs typeface="Syne" pitchFamily="34" charset="-120"/>
               </a:rPr>
-              <a:t>REFERENCES</a:t>
+              <a:t>WHERE THIS GOES</a:t>
             </a:r>
             <a:endParaRPr lang="en-US" sz="1100" dirty="0"/>
           </a:p>
@@ -9643,7 +9756,7 @@
                 <a:ea typeface="Syne" pitchFamily="34" charset="-122"/>
                 <a:cs typeface="Syne" pitchFamily="34" charset="-120"/>
               </a:rPr>
-              <a:t>The literature this stands on</a:t>
+              <a:t>Roadmap</a:t>
             </a:r>
             <a:endParaRPr lang="en-US" sz="2600" dirty="0"/>
           </a:p>
@@ -9794,17 +9907,17 @@
               <a:buChar char="•"/>
             </a:pPr>
             <a:r>
-              <a:rPr lang="en-US" sz="1300" dirty="0">
-                <a:solidFill>
-                  <a:srgbClr val="655E74"/>
-                </a:solidFill>
-                <a:latin typeface="Manrope" pitchFamily="34" charset="0"/>
-                <a:ea typeface="Manrope" pitchFamily="34" charset="-122"/>
-                <a:cs typeface="Manrope" pitchFamily="34" charset="-120"/>
-              </a:rPr>
-              <a:t>Lost in the Middle, Liu et al., arXiv:2307.03172.</a:t>
-            </a:r>
-            <a:endParaRPr lang="en-US" sz="1300" dirty="0"/>
+              <a:rPr lang="en-US" sz="1350" dirty="0">
+                <a:solidFill>
+                  <a:srgbClr val="2E2C32"/>
+                </a:solidFill>
+                <a:latin typeface="Manrope" pitchFamily="34" charset="0"/>
+                <a:ea typeface="Manrope" pitchFamily="34" charset="-122"/>
+                <a:cs typeface="Manrope" pitchFamily="34" charset="-120"/>
+              </a:rPr>
+              <a:t>EXP-003c done: the model axis shows the smart-vs-blind gap widens with capability.</a:t>
+            </a:r>
+            <a:endParaRPr lang="en-US" sz="1350" dirty="0"/>
           </a:p>
           <a:p>
             <a:pPr marL="203200" indent="-203200">
@@ -9815,17 +9928,17 @@
               <a:buChar char="•"/>
             </a:pPr>
             <a:r>
-              <a:rPr lang="en-US" sz="1300" dirty="0">
-                <a:solidFill>
-                  <a:srgbClr val="655E74"/>
-                </a:solidFill>
-                <a:latin typeface="Manrope" pitchFamily="34" charset="0"/>
-                <a:ea typeface="Manrope" pitchFamily="34" charset="-122"/>
-                <a:cs typeface="Manrope" pitchFamily="34" charset="-120"/>
-              </a:rPr>
-              <a:t>RULER 2404.06654 · HELMET 2410.02694 · NoLiMa 2502.05167.</a:t>
-            </a:r>
-            <a:endParaRPr lang="en-US" sz="1300" dirty="0"/>
+              <a:rPr lang="en-US" sz="1350" dirty="0">
+                <a:solidFill>
+                  <a:srgbClr val="2E2C32"/>
+                </a:solidFill>
+                <a:latin typeface="Manrope" pitchFamily="34" charset="0"/>
+                <a:ea typeface="Manrope" pitchFamily="34" charset="-122"/>
+                <a:cs typeface="Manrope" pitchFamily="34" charset="-120"/>
+              </a:rPr>
+              <a:t>EXP-004: LoCoMo conversational memory, the second domain.</a:t>
+            </a:r>
+            <a:endParaRPr lang="en-US" sz="1350" dirty="0"/>
           </a:p>
           <a:p>
             <a:pPr marL="203200" indent="-203200">
@@ -9836,17 +9949,17 @@
               <a:buChar char="•"/>
             </a:pPr>
             <a:r>
-              <a:rPr lang="en-US" sz="1300" dirty="0">
-                <a:solidFill>
-                  <a:srgbClr val="655E74"/>
-                </a:solidFill>
-                <a:latin typeface="Manrope" pitchFamily="34" charset="0"/>
-                <a:ea typeface="Manrope" pitchFamily="34" charset="-122"/>
-                <a:cs typeface="Manrope" pitchFamily="34" charset="-120"/>
-              </a:rPr>
-              <a:t>MemGPT 2310.08560 · Mem0 2504.19413 · ACON 2510.00615.</a:t>
-            </a:r>
-            <a:endParaRPr lang="en-US" sz="1300" dirty="0"/>
+              <a:rPr lang="en-US" sz="1350" dirty="0">
+                <a:solidFill>
+                  <a:srgbClr val="2E2C32"/>
+                </a:solidFill>
+                <a:latin typeface="Manrope" pitchFamily="34" charset="0"/>
+                <a:ea typeface="Manrope" pitchFamily="34" charset="-122"/>
+                <a:cs typeface="Manrope" pitchFamily="34" charset="-120"/>
+              </a:rPr>
+              <a:t>Hold the summarizer constant across tiers; larger N for tighter error bars.</a:t>
+            </a:r>
+            <a:endParaRPr lang="en-US" sz="1350" dirty="0"/>
           </a:p>
           <a:p>
             <a:pPr marL="203200" indent="-203200">
@@ -9857,38 +9970,17 @@
               <a:buChar char="•"/>
             </a:pPr>
             <a:r>
-              <a:rPr lang="en-US" sz="1300" dirty="0">
-                <a:solidFill>
-                  <a:srgbClr val="655E74"/>
-                </a:solidFill>
-                <a:latin typeface="Manrope" pitchFamily="34" charset="0"/>
-                <a:ea typeface="Manrope" pitchFamily="34" charset="-122"/>
-                <a:cs typeface="Manrope" pitchFamily="34" charset="-120"/>
-              </a:rPr>
-              <a:t>Judging LLM-as-a-Judge, Zheng et al., 2306.05685.</a:t>
-            </a:r>
-            <a:endParaRPr lang="en-US" sz="1300" dirty="0"/>
-          </a:p>
-          <a:p>
-            <a:pPr marL="203200" indent="-203200">
-              <a:spcAft>
-                <a:spcPts val="800"/>
-              </a:spcAft>
-              <a:buSzPct val="100000"/>
-              <a:buChar char="•"/>
-            </a:pPr>
-            <a:r>
-              <a:rPr lang="en-US" sz="1300" dirty="0">
-                <a:solidFill>
-                  <a:srgbClr val="655E74"/>
-                </a:solidFill>
-                <a:latin typeface="Manrope" pitchFamily="34" charset="0"/>
-                <a:ea typeface="Manrope" pitchFamily="34" charset="-122"/>
-                <a:cs typeface="Manrope" pitchFamily="34" charset="-120"/>
-              </a:rPr>
-              <a:t>FRAMES 2409.12941 · LoCoMo 2402.17753.</a:t>
-            </a:r>
-            <a:endParaRPr lang="en-US" sz="1300" dirty="0"/>
+              <a:rPr lang="en-US" sz="1350" dirty="0">
+                <a:solidFill>
+                  <a:srgbClr val="2E2C32"/>
+                </a:solidFill>
+                <a:latin typeface="Manrope" pitchFamily="34" charset="0"/>
+                <a:ea typeface="Manrope" pitchFamily="34" charset="-122"/>
+                <a:cs typeface="Manrope" pitchFamily="34" charset="-120"/>
+              </a:rPr>
+              <a:t>LangChain summary-memory as a baseline arm; then the paper.</a:t>
+            </a:r>
+            <a:endParaRPr lang="en-US" sz="1350" dirty="0"/>
           </a:p>
         </p:txBody>
       </p:sp>
@@ -9903,6 +9995,359 @@
 <file path=ppt/slides/slide27.xml><?xml version="1.0" encoding="utf-8"?>
 <p:sld xmlns:a="http://schemas.openxmlformats.org/drawingml/2006/main" xmlns:r="http://schemas.openxmlformats.org/officeDocument/2006/relationships" xmlns:p="http://schemas.openxmlformats.org/presentationml/2006/main">
   <p:cSld name="Slide 27">
+    <p:bg>
+      <p:bgPr>
+        <a:solidFill>
+          <a:srgbClr val="FAFAFE"/>
+        </a:solidFill>
+      </p:bgPr>
+    </p:bg>
+    <p:spTree>
+      <p:nvGrpSpPr>
+        <p:cNvPr id="1" name=""/>
+        <p:cNvGrpSpPr/>
+        <p:nvPr/>
+      </p:nvGrpSpPr>
+      <p:grpSpPr>
+        <a:xfrm>
+          <a:off x="0" y="0"/>
+          <a:ext cx="0" cy="0"/>
+          <a:chOff x="0" y="0"/>
+          <a:chExt cx="0" cy="0"/>
+        </a:xfrm>
+      </p:grpSpPr>
+      <p:sp>
+        <p:nvSpPr>
+          <p:cNvPr id="2" name="Text 0"/>
+          <p:cNvSpPr/>
+          <p:nvPr/>
+        </p:nvSpPr>
+        <p:spPr>
+          <a:xfrm>
+            <a:off x="548640" y="365760"/>
+            <a:ext cx="8046720" cy="274320"/>
+          </a:xfrm>
+          <a:prstGeom prst="rect">
+            <a:avLst/>
+          </a:prstGeom>
+          <a:noFill/>
+          <a:ln/>
+        </p:spPr>
+        <p:txBody>
+          <a:bodyPr wrap="square" lIns="0" tIns="0" rIns="0" bIns="0" rtlCol="0" anchor="ctr"/>
+          <a:lstStyle/>
+          <a:p>
+            <a:pPr indent="0" marL="0">
+              <a:buNone/>
+            </a:pPr>
+            <a:r>
+              <a:rPr lang="en-US" sz="1100" b="1" spc="300" kern="0" dirty="0">
+                <a:solidFill>
+                  <a:srgbClr val="9378FF"/>
+                </a:solidFill>
+                <a:latin typeface="Syne" pitchFamily="34" charset="0"/>
+                <a:ea typeface="Syne" pitchFamily="34" charset="-122"/>
+                <a:cs typeface="Syne" pitchFamily="34" charset="-120"/>
+              </a:rPr>
+              <a:t>REFERENCES</a:t>
+            </a:r>
+            <a:endParaRPr lang="en-US" sz="1100" dirty="0"/>
+          </a:p>
+        </p:txBody>
+      </p:sp>
+      <p:sp>
+        <p:nvSpPr>
+          <p:cNvPr id="3" name="Text 1"/>
+          <p:cNvSpPr/>
+          <p:nvPr/>
+        </p:nvSpPr>
+        <p:spPr>
+          <a:xfrm>
+            <a:off x="548640" y="640080"/>
+            <a:ext cx="8046720" cy="868680"/>
+          </a:xfrm>
+          <a:prstGeom prst="rect">
+            <a:avLst/>
+          </a:prstGeom>
+          <a:noFill/>
+          <a:ln/>
+        </p:spPr>
+        <p:txBody>
+          <a:bodyPr wrap="square" lIns="0" tIns="0" rIns="0" bIns="0" rtlCol="0" anchor="t"/>
+          <a:lstStyle/>
+          <a:p>
+            <a:pPr indent="0" marL="0">
+              <a:buNone/>
+            </a:pPr>
+            <a:r>
+              <a:rPr lang="en-US" sz="2700" b="1" dirty="0">
+                <a:solidFill>
+                  <a:srgbClr val="2E2C32"/>
+                </a:solidFill>
+                <a:latin typeface="Syne" pitchFamily="34" charset="0"/>
+                <a:ea typeface="Syne" pitchFamily="34" charset="-122"/>
+                <a:cs typeface="Syne" pitchFamily="34" charset="-120"/>
+              </a:rPr>
+              <a:t>The literature this stands on</a:t>
+            </a:r>
+            <a:endParaRPr lang="en-US" sz="2700" dirty="0"/>
+          </a:p>
+        </p:txBody>
+      </p:sp>
+      <p:pic>
+        <p:nvPicPr>
+          <p:cNvPr id="4" name="Image 0" descr="preencoded.png">    </p:cNvPr>
+          <p:cNvPicPr>
+            <a:picLocks noChangeAspect="1"/>
+          </p:cNvPicPr>
+          <p:nvPr/>
+        </p:nvPicPr>
+        <p:blipFill>
+          <a:blip r:embed="rId1"/>
+          <a:stretch>
+            <a:fillRect/>
+          </a:stretch>
+        </p:blipFill>
+        <p:spPr>
+          <a:xfrm>
+            <a:off x="548640" y="4736592"/>
+            <a:ext cx="219456" cy="165344"/>
+          </a:xfrm>
+          <a:prstGeom prst="rect">
+            <a:avLst/>
+          </a:prstGeom>
+        </p:spPr>
+      </p:pic>
+      <p:sp>
+        <p:nvSpPr>
+          <p:cNvPr id="5" name="Text 2"/>
+          <p:cNvSpPr/>
+          <p:nvPr/>
+        </p:nvSpPr>
+        <p:spPr>
+          <a:xfrm>
+            <a:off x="822960" y="4690872"/>
+            <a:ext cx="1280160" cy="292608"/>
+          </a:xfrm>
+          <a:prstGeom prst="rect">
+            <a:avLst/>
+          </a:prstGeom>
+          <a:noFill/>
+          <a:ln/>
+        </p:spPr>
+        <p:txBody>
+          <a:bodyPr wrap="square" lIns="0" tIns="0" rIns="0" bIns="0" rtlCol="0" anchor="ctr"/>
+          <a:lstStyle/>
+          <a:p>
+            <a:pPr indent="0" marL="0">
+              <a:buNone/>
+            </a:pPr>
+            <a:r>
+              <a:rPr lang="en-US" sz="1100" b="1" dirty="0">
+                <a:solidFill>
+                  <a:srgbClr val="2E2C32"/>
+                </a:solidFill>
+                <a:latin typeface="Syne" pitchFamily="34" charset="0"/>
+                <a:ea typeface="Syne" pitchFamily="34" charset="-122"/>
+                <a:cs typeface="Syne" pitchFamily="34" charset="-120"/>
+              </a:rPr>
+              <a:t>Founsi</a:t>
+            </a:r>
+            <a:pPr indent="0" marL="0">
+              <a:buNone/>
+            </a:pPr>
+            <a:r>
+              <a:rPr lang="en-US" sz="1100" b="1" dirty="0">
+                <a:solidFill>
+                  <a:srgbClr val="9378FF"/>
+                </a:solidFill>
+                <a:latin typeface="Syne" pitchFamily="34" charset="0"/>
+                <a:ea typeface="Syne" pitchFamily="34" charset="-122"/>
+                <a:cs typeface="Syne" pitchFamily="34" charset="-120"/>
+              </a:rPr>
+              <a:t>.</a:t>
+            </a:r>
+            <a:endParaRPr lang="en-US" sz="1100" dirty="0"/>
+          </a:p>
+        </p:txBody>
+      </p:sp>
+      <p:sp>
+        <p:nvSpPr>
+          <p:cNvPr id="6" name="Text 3"/>
+          <p:cNvSpPr/>
+          <p:nvPr/>
+        </p:nvSpPr>
+        <p:spPr>
+          <a:xfrm>
+            <a:off x="8229600" y="4690872"/>
+            <a:ext cx="365760" cy="292608"/>
+          </a:xfrm>
+          <a:prstGeom prst="rect">
+            <a:avLst/>
+          </a:prstGeom>
+          <a:noFill/>
+          <a:ln/>
+        </p:spPr>
+        <p:txBody>
+          <a:bodyPr wrap="square" lIns="0" tIns="0" rIns="0" bIns="0" rtlCol="0" anchor="ctr"/>
+          <a:lstStyle/>
+          <a:p>
+            <a:pPr algn="r" indent="0" marL="0">
+              <a:buNone/>
+            </a:pPr>
+            <a:r>
+              <a:rPr lang="en-US" sz="900" dirty="0">
+                <a:solidFill>
+                  <a:srgbClr val="7E7A8A"/>
+                </a:solidFill>
+                <a:latin typeface="Manrope" pitchFamily="34" charset="0"/>
+                <a:ea typeface="Manrope" pitchFamily="34" charset="-122"/>
+                <a:cs typeface="Manrope" pitchFamily="34" charset="-120"/>
+              </a:rPr>
+              <a:t>27</a:t>
+            </a:r>
+            <a:endParaRPr lang="en-US" sz="900" dirty="0"/>
+          </a:p>
+        </p:txBody>
+      </p:sp>
+      <p:sp>
+        <p:nvSpPr>
+          <p:cNvPr id="7" name="Text 4"/>
+          <p:cNvSpPr/>
+          <p:nvPr/>
+        </p:nvSpPr>
+        <p:spPr>
+          <a:xfrm>
+            <a:off x="548640" y="1645920"/>
+            <a:ext cx="8046720" cy="2834640"/>
+          </a:xfrm>
+          <a:prstGeom prst="rect">
+            <a:avLst/>
+          </a:prstGeom>
+          <a:noFill/>
+          <a:ln/>
+        </p:spPr>
+        <p:txBody>
+          <a:bodyPr wrap="square" rtlCol="0" anchor="ctr"/>
+          <a:lstStyle/>
+          <a:p>
+            <a:pPr marL="203200" indent="-203200">
+              <a:spcAft>
+                <a:spcPts val="800"/>
+              </a:spcAft>
+              <a:buSzPct val="100000"/>
+              <a:buChar char="•"/>
+            </a:pPr>
+            <a:r>
+              <a:rPr lang="en-US" sz="1300" dirty="0">
+                <a:solidFill>
+                  <a:srgbClr val="655E74"/>
+                </a:solidFill>
+                <a:latin typeface="Manrope" pitchFamily="34" charset="0"/>
+                <a:ea typeface="Manrope" pitchFamily="34" charset="-122"/>
+                <a:cs typeface="Manrope" pitchFamily="34" charset="-120"/>
+              </a:rPr>
+              <a:t>Lost in the Middle, Liu et al., arXiv:2307.03172.</a:t>
+            </a:r>
+            <a:endParaRPr lang="en-US" sz="1300" dirty="0"/>
+          </a:p>
+          <a:p>
+            <a:pPr marL="203200" indent="-203200">
+              <a:spcAft>
+                <a:spcPts val="800"/>
+              </a:spcAft>
+              <a:buSzPct val="100000"/>
+              <a:buChar char="•"/>
+            </a:pPr>
+            <a:r>
+              <a:rPr lang="en-US" sz="1300" dirty="0">
+                <a:solidFill>
+                  <a:srgbClr val="655E74"/>
+                </a:solidFill>
+                <a:latin typeface="Manrope" pitchFamily="34" charset="0"/>
+                <a:ea typeface="Manrope" pitchFamily="34" charset="-122"/>
+                <a:cs typeface="Manrope" pitchFamily="34" charset="-120"/>
+              </a:rPr>
+              <a:t>RULER 2404.06654 · HELMET 2410.02694 · NoLiMa 2502.05167.</a:t>
+            </a:r>
+            <a:endParaRPr lang="en-US" sz="1300" dirty="0"/>
+          </a:p>
+          <a:p>
+            <a:pPr marL="203200" indent="-203200">
+              <a:spcAft>
+                <a:spcPts val="800"/>
+              </a:spcAft>
+              <a:buSzPct val="100000"/>
+              <a:buChar char="•"/>
+            </a:pPr>
+            <a:r>
+              <a:rPr lang="en-US" sz="1300" dirty="0">
+                <a:solidFill>
+                  <a:srgbClr val="655E74"/>
+                </a:solidFill>
+                <a:latin typeface="Manrope" pitchFamily="34" charset="0"/>
+                <a:ea typeface="Manrope" pitchFamily="34" charset="-122"/>
+                <a:cs typeface="Manrope" pitchFamily="34" charset="-120"/>
+              </a:rPr>
+              <a:t>MemGPT 2310.08560 · Mem0 2504.19413 · ACON 2510.00615.</a:t>
+            </a:r>
+            <a:endParaRPr lang="en-US" sz="1300" dirty="0"/>
+          </a:p>
+          <a:p>
+            <a:pPr marL="203200" indent="-203200">
+              <a:spcAft>
+                <a:spcPts val="800"/>
+              </a:spcAft>
+              <a:buSzPct val="100000"/>
+              <a:buChar char="•"/>
+            </a:pPr>
+            <a:r>
+              <a:rPr lang="en-US" sz="1300" dirty="0">
+                <a:solidFill>
+                  <a:srgbClr val="655E74"/>
+                </a:solidFill>
+                <a:latin typeface="Manrope" pitchFamily="34" charset="0"/>
+                <a:ea typeface="Manrope" pitchFamily="34" charset="-122"/>
+                <a:cs typeface="Manrope" pitchFamily="34" charset="-120"/>
+              </a:rPr>
+              <a:t>Judging LLM-as-a-Judge, Zheng et al., 2306.05685.</a:t>
+            </a:r>
+            <a:endParaRPr lang="en-US" sz="1300" dirty="0"/>
+          </a:p>
+          <a:p>
+            <a:pPr marL="203200" indent="-203200">
+              <a:spcAft>
+                <a:spcPts val="800"/>
+              </a:spcAft>
+              <a:buSzPct val="100000"/>
+              <a:buChar char="•"/>
+            </a:pPr>
+            <a:r>
+              <a:rPr lang="en-US" sz="1300" dirty="0">
+                <a:solidFill>
+                  <a:srgbClr val="655E74"/>
+                </a:solidFill>
+                <a:latin typeface="Manrope" pitchFamily="34" charset="0"/>
+                <a:ea typeface="Manrope" pitchFamily="34" charset="-122"/>
+                <a:cs typeface="Manrope" pitchFamily="34" charset="-120"/>
+              </a:rPr>
+              <a:t>FRAMES 2409.12941 · LoCoMo 2402.17753.</a:t>
+            </a:r>
+            <a:endParaRPr lang="en-US" sz="1300" dirty="0"/>
+          </a:p>
+        </p:txBody>
+      </p:sp>
+    </p:spTree>
+  </p:cSld>
+  <p:clrMapOvr>
+    <a:masterClrMapping/>
+  </p:clrMapOvr>
+</p:sld>
+</file>
+
+<file path=ppt/slides/slide28.xml><?xml version="1.0" encoding="utf-8"?>
+<p:sld xmlns:a="http://schemas.openxmlformats.org/drawingml/2006/main" xmlns:r="http://schemas.openxmlformats.org/officeDocument/2006/relationships" xmlns:p="http://schemas.openxmlformats.org/presentationml/2006/main">
+  <p:cSld name="Slide 28">
     <p:bg>
       <p:bgPr>
         <a:solidFill>
@@ -10364,7 +10809,7 @@
                 <a:ea typeface="Manrope" pitchFamily="34" charset="-122"/>
                 <a:cs typeface="Manrope" pitchFamily="34" charset="-120"/>
               </a:rPr>
-              <a:t>27</a:t>
+              <a:t>28</a:t>
             </a:r>
             <a:endParaRPr lang="en-US" sz="900" dirty="0"/>
           </a:p>

</xml_diff>